<commit_message>
Rework lubricity slide around machinery impact
Replaces the right panel of the lubricity problem slide with the three
failure modes on board — fuel injection pump plunger seizure, injector
nozzle wear and leakage, and HFRR wear scar exceedance — instead of
leading with the measured number alone. The HFRR figures now sit inside
the third item as confirmation of the first two.

Retitles the slide to name the cause directly: hydrodesulfurisation
removing the compounds that provided natural lubricity.

Co-Authored-By: Claude Opus 5 <noreply@anthropic.com>
Claude-Session: https://claude.ai/code/session_0181AXsH7YB1d1u5cHBfg2wM
</commit_message>
<xml_diff>
--- a/deck/fuel_training_deck.pptx
+++ b/deck/fuel_training_deck.pptx
@@ -1692,7 +1692,7 @@
           <a:p>
             <a:r>
               <a:rPr lang="en-US" dirty="0"/>
-              <a:t>Section 01에서 그은 경계선의 가장 깨끗한 사례입니다. 윤활성은 고형분이나 물처럼 분리해낼 수 있는 대상이 아니라 연료 자체의 화학적 성질입니다. 원심분리기를 아무리 잘 돌려도 535 µm는 535 µm 그대로입니다. 그리고 이 시험의 ULSD는 다른 ISO 항목은 모두 만족한 정상 연료입니다 — 슬라이드 03에서 본 착시와 정확히 같은 구조입니다.</a:t>
+              <a:t>왼쪽은 왜 이런 일이 생기는지, 오른쪽은 그래서 본선에서 무엇이 망가지는지입니다. 세 번째 항목이 앞의 두 가지를 숫자로 확인해 주는 구조입니다. 플런저-배럴 공차가 수 마이크론이라는 점을 강조하십시오 — 유막 두께가 그보다 얇아지는 순간 바로 금속끼리 닿습니다. 그리고 이 ULSD는 다른 ISO 항목은 전부 만족한 정상 연료입니다. 슬라이드 03의 착시와 같은 구조이고, 원심분리기로는 535 µm를 단 1 µm도 낮출 수 없습니다.</a:t>
             </a:r>
             <a:endParaRPr lang="en-US" dirty="0"/>
           </a:p>
@@ -17156,7 +17156,7 @@
               <a:buNone/>
             </a:pPr>
             <a:r>
-              <a:rPr lang="en-US" sz="3600" dirty="0">
+              <a:rPr lang="en-US" sz="3200" dirty="0">
                 <a:solidFill>
                   <a:srgbClr val="1B3A5C"/>
                 </a:solidFill>
@@ -17164,9 +17164,9 @@
                 <a:ea typeface="바탕" pitchFamily="34" charset="-122"/>
                 <a:cs typeface="바탕" pitchFamily="34" charset="-120"/>
               </a:rPr>
-              <a:t>황을 뺐더니 윤활성이 함께 빠졌습니다</a:t>
-            </a:r>
-            <a:endParaRPr lang="en-US" sz="3600" dirty="0"/>
+              <a:t>탈황 공정 중 천연 윤활 역할을 하던 성분 동시 제거</a:t>
+            </a:r>
+            <a:endParaRPr lang="en-US" sz="3200" dirty="0"/>
           </a:p>
         </p:txBody>
       </p:sp>
@@ -17257,11 +17257,11 @@
         <p:spPr>
           <a:xfrm>
             <a:off x="566928" y="1591056"/>
-            <a:ext cx="5486400" cy="3127248"/>
+            <a:ext cx="4315968" cy="3255264"/>
           </a:xfrm>
           <a:prstGeom prst="roundRect">
             <a:avLst>
-              <a:gd name="adj" fmla="val 4094"/>
+              <a:gd name="adj" fmla="val 3933"/>
             </a:avLst>
           </a:prstGeom>
           <a:solidFill>
@@ -17290,8 +17290,8 @@
         </p:nvSpPr>
         <p:spPr>
           <a:xfrm>
-            <a:off x="822960" y="1792224"/>
-            <a:ext cx="4023360" cy="219456"/>
+            <a:off x="804672" y="1792224"/>
+            <a:ext cx="3840480" cy="219456"/>
           </a:xfrm>
           <a:prstGeom prst="rect">
             <a:avLst/>
@@ -17323,52 +17323,13 @@
       </p:sp>
       <p:sp>
         <p:nvSpPr>
-          <p:cNvPr id="8" name="Text 6"/>
-          <p:cNvSpPr/>
-          <p:nvPr/>
-        </p:nvSpPr>
-        <p:spPr>
-          <a:xfrm>
-            <a:off x="822960" y="2011680"/>
-            <a:ext cx="4974336" cy="292608"/>
-          </a:xfrm>
-          <a:prstGeom prst="rect">
-            <a:avLst/>
-          </a:prstGeom>
-          <a:noFill/>
-          <a:ln/>
-        </p:spPr>
-        <p:txBody>
-          <a:bodyPr wrap="square" lIns="0" tIns="0" rIns="0" bIns="0" rtlCol="0" anchor="ctr"/>
-          <a:lstStyle/>
-          <a:p>
-            <a:pPr indent="0" marL="0">
-              <a:buNone/>
-            </a:pPr>
-            <a:r>
-              <a:rPr lang="en-US" sz="1400" b="1" dirty="0">
-                <a:solidFill>
-                  <a:srgbClr val="1B3A5C"/>
-                </a:solidFill>
-                <a:latin typeface="맑은 고딕" pitchFamily="34" charset="0"/>
-                <a:ea typeface="맑은 고딕" pitchFamily="34" charset="-122"/>
-                <a:cs typeface="맑은 고딕" pitchFamily="34" charset="-120"/>
-              </a:rPr>
-              <a:t>규제가 만든 연쇄</a:t>
-            </a:r>
-            <a:endParaRPr lang="en-US" sz="1400" dirty="0"/>
-          </a:p>
-        </p:txBody>
-      </p:sp>
-      <p:sp>
-        <p:nvSpPr>
-          <p:cNvPr id="9" name="Shape 7"/>
-          <p:cNvSpPr/>
-          <p:nvPr/>
-        </p:nvSpPr>
-        <p:spPr>
-          <a:xfrm>
-            <a:off x="822960" y="2450592"/>
+          <p:cNvPr id="8" name="Shape 6"/>
+          <p:cNvSpPr/>
+          <p:nvPr/>
+        </p:nvSpPr>
+        <p:spPr>
+          <a:xfrm>
+            <a:off x="804672" y="2194560"/>
             <a:ext cx="274320" cy="274320"/>
           </a:xfrm>
           <a:prstGeom prst="roundRect">
@@ -17389,14 +17350,131 @@
       </p:sp>
       <p:sp>
         <p:nvSpPr>
+          <p:cNvPr id="9" name="Text 7"/>
+          <p:cNvSpPr/>
+          <p:nvPr/>
+        </p:nvSpPr>
+        <p:spPr>
+          <a:xfrm>
+            <a:off x="804672" y="2194560"/>
+            <a:ext cx="274320" cy="274320"/>
+          </a:xfrm>
+          <a:prstGeom prst="rect">
+            <a:avLst/>
+          </a:prstGeom>
+          <a:noFill/>
+          <a:ln/>
+        </p:spPr>
+        <p:txBody>
+          <a:bodyPr wrap="square" lIns="0" tIns="0" rIns="0" bIns="0" rtlCol="0" anchor="ctr"/>
+          <a:lstStyle/>
+          <a:p>
+            <a:pPr algn="ctr" indent="0" marL="0">
+              <a:buNone/>
+            </a:pPr>
+            <a:r>
+              <a:rPr lang="en-US" sz="1000" b="1" dirty="0">
+                <a:solidFill>
+                  <a:srgbClr val="FFFFFF"/>
+                </a:solidFill>
+                <a:latin typeface="맑은 고딕" pitchFamily="34" charset="0"/>
+                <a:ea typeface="맑은 고딕" pitchFamily="34" charset="-122"/>
+                <a:cs typeface="맑은 고딕" pitchFamily="34" charset="-120"/>
+              </a:rPr>
+              <a:t>1</a:t>
+            </a:r>
+            <a:endParaRPr lang="en-US" sz="1000" dirty="0"/>
+          </a:p>
+        </p:txBody>
+      </p:sp>
+      <p:sp>
+        <p:nvSpPr>
           <p:cNvPr id="10" name="Text 8"/>
           <p:cNvSpPr/>
           <p:nvPr/>
         </p:nvSpPr>
         <p:spPr>
           <a:xfrm>
-            <a:off x="822960" y="2450592"/>
-            <a:ext cx="274320" cy="274320"/>
+            <a:off x="1188720" y="2157984"/>
+            <a:ext cx="3456432" cy="310896"/>
+          </a:xfrm>
+          <a:prstGeom prst="rect">
+            <a:avLst/>
+          </a:prstGeom>
+          <a:noFill/>
+          <a:ln/>
+        </p:spPr>
+        <p:txBody>
+          <a:bodyPr wrap="square" lIns="0" tIns="0" rIns="0" bIns="0" rtlCol="0" anchor="ctr"/>
+          <a:lstStyle/>
+          <a:p>
+            <a:pPr indent="0" marL="0">
+              <a:buNone/>
+            </a:pPr>
+            <a:r>
+              <a:rPr lang="en-US" sz="1250" b="1" dirty="0">
+                <a:solidFill>
+                  <a:srgbClr val="1B3A5C"/>
+                </a:solidFill>
+                <a:latin typeface="맑은 고딕" pitchFamily="34" charset="0"/>
+                <a:ea typeface="맑은 고딕" pitchFamily="34" charset="-122"/>
+                <a:cs typeface="맑은 고딕" pitchFamily="34" charset="-120"/>
+              </a:rPr>
+              <a:t>ECA · SECA 확대</a:t>
+            </a:r>
+            <a:endParaRPr lang="en-US" sz="1250" dirty="0"/>
+          </a:p>
+        </p:txBody>
+      </p:sp>
+      <p:sp>
+        <p:nvSpPr>
+          <p:cNvPr id="11" name="Text 9"/>
+          <p:cNvSpPr/>
+          <p:nvPr/>
+        </p:nvSpPr>
+        <p:spPr>
+          <a:xfrm>
+            <a:off x="1188720" y="2450592"/>
+            <a:ext cx="3456432" cy="256032"/>
+          </a:xfrm>
+          <a:prstGeom prst="rect">
+            <a:avLst/>
+          </a:prstGeom>
+          <a:noFill/>
+          <a:ln/>
+        </p:spPr>
+        <p:txBody>
+          <a:bodyPr wrap="square" lIns="0" tIns="0" rIns="0" bIns="0" rtlCol="0" anchor="ctr"/>
+          <a:lstStyle/>
+          <a:p>
+            <a:pPr indent="0" marL="0">
+              <a:buNone/>
+            </a:pPr>
+            <a:r>
+              <a:rPr lang="en-US" sz="1050" dirty="0">
+                <a:solidFill>
+                  <a:srgbClr val="3D4A5C"/>
+                </a:solidFill>
+                <a:latin typeface="맑은 고딕" pitchFamily="34" charset="0"/>
+                <a:ea typeface="맑은 고딕" pitchFamily="34" charset="-122"/>
+                <a:cs typeface="맑은 고딕" pitchFamily="34" charset="-120"/>
+              </a:rPr>
+              <a:t>저유황 디젤 사용 의무</a:t>
+            </a:r>
+            <a:endParaRPr lang="en-US" sz="1050" dirty="0"/>
+          </a:p>
+        </p:txBody>
+      </p:sp>
+      <p:sp>
+        <p:nvSpPr>
+          <p:cNvPr id="12" name="Text 10"/>
+          <p:cNvSpPr/>
+          <p:nvPr/>
+        </p:nvSpPr>
+        <p:spPr>
+          <a:xfrm>
+            <a:off x="804672" y="2505456"/>
+            <a:ext cx="274320" cy="237744"/>
           </a:xfrm>
           <a:prstGeom prst="rect">
             <a:avLst/>
@@ -17412,123 +17490,6 @@
               <a:buNone/>
             </a:pPr>
             <a:r>
-              <a:rPr lang="en-US" sz="1000" b="1" dirty="0">
-                <a:solidFill>
-                  <a:srgbClr val="FFFFFF"/>
-                </a:solidFill>
-                <a:latin typeface="맑은 고딕" pitchFamily="34" charset="0"/>
-                <a:ea typeface="맑은 고딕" pitchFamily="34" charset="-122"/>
-                <a:cs typeface="맑은 고딕" pitchFamily="34" charset="-120"/>
-              </a:rPr>
-              <a:t>1</a:t>
-            </a:r>
-            <a:endParaRPr lang="en-US" sz="1000" dirty="0"/>
-          </a:p>
-        </p:txBody>
-      </p:sp>
-      <p:sp>
-        <p:nvSpPr>
-          <p:cNvPr id="11" name="Text 9"/>
-          <p:cNvSpPr/>
-          <p:nvPr/>
-        </p:nvSpPr>
-        <p:spPr>
-          <a:xfrm>
-            <a:off x="1207008" y="2414016"/>
-            <a:ext cx="2103120" cy="347472"/>
-          </a:xfrm>
-          <a:prstGeom prst="rect">
-            <a:avLst/>
-          </a:prstGeom>
-          <a:noFill/>
-          <a:ln/>
-        </p:spPr>
-        <p:txBody>
-          <a:bodyPr wrap="square" lIns="0" tIns="0" rIns="0" bIns="0" rtlCol="0" anchor="ctr"/>
-          <a:lstStyle/>
-          <a:p>
-            <a:pPr indent="0" marL="0">
-              <a:buNone/>
-            </a:pPr>
-            <a:r>
-              <a:rPr lang="en-US" sz="1200" b="1" dirty="0">
-                <a:solidFill>
-                  <a:srgbClr val="1B3A5C"/>
-                </a:solidFill>
-                <a:latin typeface="맑은 고딕" pitchFamily="34" charset="0"/>
-                <a:ea typeface="맑은 고딕" pitchFamily="34" charset="-122"/>
-                <a:cs typeface="맑은 고딕" pitchFamily="34" charset="-120"/>
-              </a:rPr>
-              <a:t>ECA · SECA 확대</a:t>
-            </a:r>
-            <a:endParaRPr lang="en-US" sz="1200" dirty="0"/>
-          </a:p>
-        </p:txBody>
-      </p:sp>
-      <p:sp>
-        <p:nvSpPr>
-          <p:cNvPr id="12" name="Text 10"/>
-          <p:cNvSpPr/>
-          <p:nvPr/>
-        </p:nvSpPr>
-        <p:spPr>
-          <a:xfrm>
-            <a:off x="3346704" y="2414016"/>
-            <a:ext cx="2450592" cy="347472"/>
-          </a:xfrm>
-          <a:prstGeom prst="rect">
-            <a:avLst/>
-          </a:prstGeom>
-          <a:noFill/>
-          <a:ln/>
-        </p:spPr>
-        <p:txBody>
-          <a:bodyPr wrap="square" lIns="0" tIns="0" rIns="0" bIns="0" rtlCol="0" anchor="ctr"/>
-          <a:lstStyle/>
-          <a:p>
-            <a:pPr indent="0" marL="0">
-              <a:buNone/>
-            </a:pPr>
-            <a:r>
-              <a:rPr lang="en-US" sz="1050" dirty="0">
-                <a:solidFill>
-                  <a:srgbClr val="3D4A5C"/>
-                </a:solidFill>
-                <a:latin typeface="맑은 고딕" pitchFamily="34" charset="0"/>
-                <a:ea typeface="맑은 고딕" pitchFamily="34" charset="-122"/>
-                <a:cs typeface="맑은 고딕" pitchFamily="34" charset="-120"/>
-              </a:rPr>
-              <a:t>저유황 디젤 사용 의무</a:t>
-            </a:r>
-            <a:endParaRPr lang="en-US" sz="1050" dirty="0"/>
-          </a:p>
-        </p:txBody>
-      </p:sp>
-      <p:sp>
-        <p:nvSpPr>
-          <p:cNvPr id="13" name="Text 11"/>
-          <p:cNvSpPr/>
-          <p:nvPr/>
-        </p:nvSpPr>
-        <p:spPr>
-          <a:xfrm>
-            <a:off x="822960" y="2743200"/>
-            <a:ext cx="274320" cy="182880"/>
-          </a:xfrm>
-          <a:prstGeom prst="rect">
-            <a:avLst/>
-          </a:prstGeom>
-          <a:noFill/>
-          <a:ln/>
-        </p:spPr>
-        <p:txBody>
-          <a:bodyPr wrap="square" lIns="0" tIns="0" rIns="0" bIns="0" rtlCol="0" anchor="ctr"/>
-          <a:lstStyle/>
-          <a:p>
-            <a:pPr algn="ctr" indent="0" marL="0">
-              <a:buNone/>
-            </a:pPr>
-            <a:r>
               <a:rPr lang="en-US" sz="700" dirty="0">
                 <a:solidFill>
                   <a:srgbClr val="B9C4D6"/>
@@ -17545,13 +17506,13 @@
       </p:sp>
       <p:sp>
         <p:nvSpPr>
-          <p:cNvPr id="14" name="Shape 12"/>
-          <p:cNvSpPr/>
-          <p:nvPr/>
-        </p:nvSpPr>
-        <p:spPr>
-          <a:xfrm>
-            <a:off x="822960" y="2999232"/>
+          <p:cNvPr id="13" name="Shape 11"/>
+          <p:cNvSpPr/>
+          <p:nvPr/>
+        </p:nvSpPr>
+        <p:spPr>
+          <a:xfrm>
+            <a:off x="804672" y="2852928"/>
             <a:ext cx="274320" cy="274320"/>
           </a:xfrm>
           <a:prstGeom prst="roundRect">
@@ -17572,14 +17533,131 @@
       </p:sp>
       <p:sp>
         <p:nvSpPr>
+          <p:cNvPr id="14" name="Text 12"/>
+          <p:cNvSpPr/>
+          <p:nvPr/>
+        </p:nvSpPr>
+        <p:spPr>
+          <a:xfrm>
+            <a:off x="804672" y="2852928"/>
+            <a:ext cx="274320" cy="274320"/>
+          </a:xfrm>
+          <a:prstGeom prst="rect">
+            <a:avLst/>
+          </a:prstGeom>
+          <a:noFill/>
+          <a:ln/>
+        </p:spPr>
+        <p:txBody>
+          <a:bodyPr wrap="square" lIns="0" tIns="0" rIns="0" bIns="0" rtlCol="0" anchor="ctr"/>
+          <a:lstStyle/>
+          <a:p>
+            <a:pPr algn="ctr" indent="0" marL="0">
+              <a:buNone/>
+            </a:pPr>
+            <a:r>
+              <a:rPr lang="en-US" sz="1000" b="1" dirty="0">
+                <a:solidFill>
+                  <a:srgbClr val="FFFFFF"/>
+                </a:solidFill>
+                <a:latin typeface="맑은 고딕" pitchFamily="34" charset="0"/>
+                <a:ea typeface="맑은 고딕" pitchFamily="34" charset="-122"/>
+                <a:cs typeface="맑은 고딕" pitchFamily="34" charset="-120"/>
+              </a:rPr>
+              <a:t>2</a:t>
+            </a:r>
+            <a:endParaRPr lang="en-US" sz="1000" dirty="0"/>
+          </a:p>
+        </p:txBody>
+      </p:sp>
+      <p:sp>
+        <p:nvSpPr>
           <p:cNvPr id="15" name="Text 13"/>
           <p:cNvSpPr/>
           <p:nvPr/>
         </p:nvSpPr>
         <p:spPr>
           <a:xfrm>
-            <a:off x="822960" y="2999232"/>
-            <a:ext cx="274320" cy="274320"/>
+            <a:off x="1188720" y="2816352"/>
+            <a:ext cx="3456432" cy="310896"/>
+          </a:xfrm>
+          <a:prstGeom prst="rect">
+            <a:avLst/>
+          </a:prstGeom>
+          <a:noFill/>
+          <a:ln/>
+        </p:spPr>
+        <p:txBody>
+          <a:bodyPr wrap="square" lIns="0" tIns="0" rIns="0" bIns="0" rtlCol="0" anchor="ctr"/>
+          <a:lstStyle/>
+          <a:p>
+            <a:pPr indent="0" marL="0">
+              <a:buNone/>
+            </a:pPr>
+            <a:r>
+              <a:rPr lang="en-US" sz="1250" b="1" dirty="0">
+                <a:solidFill>
+                  <a:srgbClr val="1B3A5C"/>
+                </a:solidFill>
+                <a:latin typeface="맑은 고딕" pitchFamily="34" charset="0"/>
+                <a:ea typeface="맑은 고딕" pitchFamily="34" charset="-122"/>
+                <a:cs typeface="맑은 고딕" pitchFamily="34" charset="-120"/>
+              </a:rPr>
+              <a:t>탈황 정제</a:t>
+            </a:r>
+            <a:endParaRPr lang="en-US" sz="1250" dirty="0"/>
+          </a:p>
+        </p:txBody>
+      </p:sp>
+      <p:sp>
+        <p:nvSpPr>
+          <p:cNvPr id="16" name="Text 14"/>
+          <p:cNvSpPr/>
+          <p:nvPr/>
+        </p:nvSpPr>
+        <p:spPr>
+          <a:xfrm>
+            <a:off x="1188720" y="3108960"/>
+            <a:ext cx="3456432" cy="256032"/>
+          </a:xfrm>
+          <a:prstGeom prst="rect">
+            <a:avLst/>
+          </a:prstGeom>
+          <a:noFill/>
+          <a:ln/>
+        </p:spPr>
+        <p:txBody>
+          <a:bodyPr wrap="square" lIns="0" tIns="0" rIns="0" bIns="0" rtlCol="0" anchor="ctr"/>
+          <a:lstStyle/>
+          <a:p>
+            <a:pPr indent="0" marL="0">
+              <a:buNone/>
+            </a:pPr>
+            <a:r>
+              <a:rPr lang="en-US" sz="1050" dirty="0">
+                <a:solidFill>
+                  <a:srgbClr val="3D4A5C"/>
+                </a:solidFill>
+                <a:latin typeface="맑은 고딕" pitchFamily="34" charset="0"/>
+                <a:ea typeface="맑은 고딕" pitchFamily="34" charset="-122"/>
+                <a:cs typeface="맑은 고딕" pitchFamily="34" charset="-120"/>
+              </a:rPr>
+              <a:t>황을 걷어내는 공정</a:t>
+            </a:r>
+            <a:endParaRPr lang="en-US" sz="1050" dirty="0"/>
+          </a:p>
+        </p:txBody>
+      </p:sp>
+      <p:sp>
+        <p:nvSpPr>
+          <p:cNvPr id="17" name="Text 15"/>
+          <p:cNvSpPr/>
+          <p:nvPr/>
+        </p:nvSpPr>
+        <p:spPr>
+          <a:xfrm>
+            <a:off x="804672" y="3163824"/>
+            <a:ext cx="274320" cy="237744"/>
           </a:xfrm>
           <a:prstGeom prst="rect">
             <a:avLst/>
@@ -17595,123 +17673,6 @@
               <a:buNone/>
             </a:pPr>
             <a:r>
-              <a:rPr lang="en-US" sz="1000" b="1" dirty="0">
-                <a:solidFill>
-                  <a:srgbClr val="FFFFFF"/>
-                </a:solidFill>
-                <a:latin typeface="맑은 고딕" pitchFamily="34" charset="0"/>
-                <a:ea typeface="맑은 고딕" pitchFamily="34" charset="-122"/>
-                <a:cs typeface="맑은 고딕" pitchFamily="34" charset="-120"/>
-              </a:rPr>
-              <a:t>2</a:t>
-            </a:r>
-            <a:endParaRPr lang="en-US" sz="1000" dirty="0"/>
-          </a:p>
-        </p:txBody>
-      </p:sp>
-      <p:sp>
-        <p:nvSpPr>
-          <p:cNvPr id="16" name="Text 14"/>
-          <p:cNvSpPr/>
-          <p:nvPr/>
-        </p:nvSpPr>
-        <p:spPr>
-          <a:xfrm>
-            <a:off x="1207008" y="2962656"/>
-            <a:ext cx="2103120" cy="347472"/>
-          </a:xfrm>
-          <a:prstGeom prst="rect">
-            <a:avLst/>
-          </a:prstGeom>
-          <a:noFill/>
-          <a:ln/>
-        </p:spPr>
-        <p:txBody>
-          <a:bodyPr wrap="square" lIns="0" tIns="0" rIns="0" bIns="0" rtlCol="0" anchor="ctr"/>
-          <a:lstStyle/>
-          <a:p>
-            <a:pPr indent="0" marL="0">
-              <a:buNone/>
-            </a:pPr>
-            <a:r>
-              <a:rPr lang="en-US" sz="1200" b="1" dirty="0">
-                <a:solidFill>
-                  <a:srgbClr val="1B3A5C"/>
-                </a:solidFill>
-                <a:latin typeface="맑은 고딕" pitchFamily="34" charset="0"/>
-                <a:ea typeface="맑은 고딕" pitchFamily="34" charset="-122"/>
-                <a:cs typeface="맑은 고딕" pitchFamily="34" charset="-120"/>
-              </a:rPr>
-              <a:t>탈황 정제 강화</a:t>
-            </a:r>
-            <a:endParaRPr lang="en-US" sz="1200" dirty="0"/>
-          </a:p>
-        </p:txBody>
-      </p:sp>
-      <p:sp>
-        <p:nvSpPr>
-          <p:cNvPr id="17" name="Text 15"/>
-          <p:cNvSpPr/>
-          <p:nvPr/>
-        </p:nvSpPr>
-        <p:spPr>
-          <a:xfrm>
-            <a:off x="3346704" y="2962656"/>
-            <a:ext cx="2450592" cy="347472"/>
-          </a:xfrm>
-          <a:prstGeom prst="rect">
-            <a:avLst/>
-          </a:prstGeom>
-          <a:noFill/>
-          <a:ln/>
-        </p:spPr>
-        <p:txBody>
-          <a:bodyPr wrap="square" lIns="0" tIns="0" rIns="0" bIns="0" rtlCol="0" anchor="ctr"/>
-          <a:lstStyle/>
-          <a:p>
-            <a:pPr indent="0" marL="0">
-              <a:buNone/>
-            </a:pPr>
-            <a:r>
-              <a:rPr lang="en-US" sz="1050" dirty="0">
-                <a:solidFill>
-                  <a:srgbClr val="3D4A5C"/>
-                </a:solidFill>
-                <a:latin typeface="맑은 고딕" pitchFamily="34" charset="0"/>
-                <a:ea typeface="맑은 고딕" pitchFamily="34" charset="-122"/>
-                <a:cs typeface="맑은 고딕" pitchFamily="34" charset="-120"/>
-              </a:rPr>
-              <a:t>황을 걷어내는 공정</a:t>
-            </a:r>
-            <a:endParaRPr lang="en-US" sz="1050" dirty="0"/>
-          </a:p>
-        </p:txBody>
-      </p:sp>
-      <p:sp>
-        <p:nvSpPr>
-          <p:cNvPr id="18" name="Text 16"/>
-          <p:cNvSpPr/>
-          <p:nvPr/>
-        </p:nvSpPr>
-        <p:spPr>
-          <a:xfrm>
-            <a:off x="822960" y="3291840"/>
-            <a:ext cx="274320" cy="182880"/>
-          </a:xfrm>
-          <a:prstGeom prst="rect">
-            <a:avLst/>
-          </a:prstGeom>
-          <a:noFill/>
-          <a:ln/>
-        </p:spPr>
-        <p:txBody>
-          <a:bodyPr wrap="square" lIns="0" tIns="0" rIns="0" bIns="0" rtlCol="0" anchor="ctr"/>
-          <a:lstStyle/>
-          <a:p>
-            <a:pPr algn="ctr" indent="0" marL="0">
-              <a:buNone/>
-            </a:pPr>
-            <a:r>
               <a:rPr lang="en-US" sz="700" dirty="0">
                 <a:solidFill>
                   <a:srgbClr val="B9C4D6"/>
@@ -17728,13 +17689,13 @@
       </p:sp>
       <p:sp>
         <p:nvSpPr>
-          <p:cNvPr id="19" name="Shape 17"/>
-          <p:cNvSpPr/>
-          <p:nvPr/>
-        </p:nvSpPr>
-        <p:spPr>
-          <a:xfrm>
-            <a:off x="822960" y="3547872"/>
+          <p:cNvPr id="18" name="Shape 16"/>
+          <p:cNvSpPr/>
+          <p:nvPr/>
+        </p:nvSpPr>
+        <p:spPr>
+          <a:xfrm>
+            <a:off x="804672" y="3511296"/>
             <a:ext cx="274320" cy="274320"/>
           </a:xfrm>
           <a:prstGeom prst="roundRect">
@@ -17755,14 +17716,131 @@
       </p:sp>
       <p:sp>
         <p:nvSpPr>
+          <p:cNvPr id="19" name="Text 17"/>
+          <p:cNvSpPr/>
+          <p:nvPr/>
+        </p:nvSpPr>
+        <p:spPr>
+          <a:xfrm>
+            <a:off x="804672" y="3511296"/>
+            <a:ext cx="274320" cy="274320"/>
+          </a:xfrm>
+          <a:prstGeom prst="rect">
+            <a:avLst/>
+          </a:prstGeom>
+          <a:noFill/>
+          <a:ln/>
+        </p:spPr>
+        <p:txBody>
+          <a:bodyPr wrap="square" lIns="0" tIns="0" rIns="0" bIns="0" rtlCol="0" anchor="ctr"/>
+          <a:lstStyle/>
+          <a:p>
+            <a:pPr algn="ctr" indent="0" marL="0">
+              <a:buNone/>
+            </a:pPr>
+            <a:r>
+              <a:rPr lang="en-US" sz="1000" b="1" dirty="0">
+                <a:solidFill>
+                  <a:srgbClr val="FFFFFF"/>
+                </a:solidFill>
+                <a:latin typeface="맑은 고딕" pitchFamily="34" charset="0"/>
+                <a:ea typeface="맑은 고딕" pitchFamily="34" charset="-122"/>
+                <a:cs typeface="맑은 고딕" pitchFamily="34" charset="-120"/>
+              </a:rPr>
+              <a:t>3</a:t>
+            </a:r>
+            <a:endParaRPr lang="en-US" sz="1000" dirty="0"/>
+          </a:p>
+        </p:txBody>
+      </p:sp>
+      <p:sp>
+        <p:nvSpPr>
           <p:cNvPr id="20" name="Text 18"/>
           <p:cNvSpPr/>
           <p:nvPr/>
         </p:nvSpPr>
         <p:spPr>
           <a:xfrm>
-            <a:off x="822960" y="3547872"/>
-            <a:ext cx="274320" cy="274320"/>
+            <a:off x="1188720" y="3474720"/>
+            <a:ext cx="3456432" cy="310896"/>
+          </a:xfrm>
+          <a:prstGeom prst="rect">
+            <a:avLst/>
+          </a:prstGeom>
+          <a:noFill/>
+          <a:ln/>
+        </p:spPr>
+        <p:txBody>
+          <a:bodyPr wrap="square" lIns="0" tIns="0" rIns="0" bIns="0" rtlCol="0" anchor="ctr"/>
+          <a:lstStyle/>
+          <a:p>
+            <a:pPr indent="0" marL="0">
+              <a:buNone/>
+            </a:pPr>
+            <a:r>
+              <a:rPr lang="en-US" sz="1250" b="1" dirty="0">
+                <a:solidFill>
+                  <a:srgbClr val="1B3A5C"/>
+                </a:solidFill>
+                <a:latin typeface="맑은 고딕" pitchFamily="34" charset="0"/>
+                <a:ea typeface="맑은 고딕" pitchFamily="34" charset="-122"/>
+                <a:cs typeface="맑은 고딕" pitchFamily="34" charset="-120"/>
+              </a:rPr>
+              <a:t>극성 성분 동반 제거</a:t>
+            </a:r>
+            <a:endParaRPr lang="en-US" sz="1250" dirty="0"/>
+          </a:p>
+        </p:txBody>
+      </p:sp>
+      <p:sp>
+        <p:nvSpPr>
+          <p:cNvPr id="21" name="Text 19"/>
+          <p:cNvSpPr/>
+          <p:nvPr/>
+        </p:nvSpPr>
+        <p:spPr>
+          <a:xfrm>
+            <a:off x="1188720" y="3767328"/>
+            <a:ext cx="3456432" cy="256032"/>
+          </a:xfrm>
+          <a:prstGeom prst="rect">
+            <a:avLst/>
+          </a:prstGeom>
+          <a:noFill/>
+          <a:ln/>
+        </p:spPr>
+        <p:txBody>
+          <a:bodyPr wrap="square" lIns="0" tIns="0" rIns="0" bIns="0" rtlCol="0" anchor="ctr"/>
+          <a:lstStyle/>
+          <a:p>
+            <a:pPr indent="0" marL="0">
+              <a:buNone/>
+            </a:pPr>
+            <a:r>
+              <a:rPr lang="en-US" sz="1050" dirty="0">
+                <a:solidFill>
+                  <a:srgbClr val="3D4A5C"/>
+                </a:solidFill>
+                <a:latin typeface="맑은 고딕" pitchFamily="34" charset="0"/>
+                <a:ea typeface="맑은 고딕" pitchFamily="34" charset="-122"/>
+                <a:cs typeface="맑은 고딕" pitchFamily="34" charset="-120"/>
+              </a:rPr>
+              <a:t>천연 윤활 성분이 같이 빠짐</a:t>
+            </a:r>
+            <a:endParaRPr lang="en-US" sz="1050" dirty="0"/>
+          </a:p>
+        </p:txBody>
+      </p:sp>
+      <p:sp>
+        <p:nvSpPr>
+          <p:cNvPr id="22" name="Text 20"/>
+          <p:cNvSpPr/>
+          <p:nvPr/>
+        </p:nvSpPr>
+        <p:spPr>
+          <a:xfrm>
+            <a:off x="804672" y="3822192"/>
+            <a:ext cx="274320" cy="237744"/>
           </a:xfrm>
           <a:prstGeom prst="rect">
             <a:avLst/>
@@ -17778,123 +17856,6 @@
               <a:buNone/>
             </a:pPr>
             <a:r>
-              <a:rPr lang="en-US" sz="1000" b="1" dirty="0">
-                <a:solidFill>
-                  <a:srgbClr val="FFFFFF"/>
-                </a:solidFill>
-                <a:latin typeface="맑은 고딕" pitchFamily="34" charset="0"/>
-                <a:ea typeface="맑은 고딕" pitchFamily="34" charset="-122"/>
-                <a:cs typeface="맑은 고딕" pitchFamily="34" charset="-120"/>
-              </a:rPr>
-              <a:t>3</a:t>
-            </a:r>
-            <a:endParaRPr lang="en-US" sz="1000" dirty="0"/>
-          </a:p>
-        </p:txBody>
-      </p:sp>
-      <p:sp>
-        <p:nvSpPr>
-          <p:cNvPr id="21" name="Text 19"/>
-          <p:cNvSpPr/>
-          <p:nvPr/>
-        </p:nvSpPr>
-        <p:spPr>
-          <a:xfrm>
-            <a:off x="1207008" y="3511296"/>
-            <a:ext cx="2103120" cy="347472"/>
-          </a:xfrm>
-          <a:prstGeom prst="rect">
-            <a:avLst/>
-          </a:prstGeom>
-          <a:noFill/>
-          <a:ln/>
-        </p:spPr>
-        <p:txBody>
-          <a:bodyPr wrap="square" lIns="0" tIns="0" rIns="0" bIns="0" rtlCol="0" anchor="ctr"/>
-          <a:lstStyle/>
-          <a:p>
-            <a:pPr indent="0" marL="0">
-              <a:buNone/>
-            </a:pPr>
-            <a:r>
-              <a:rPr lang="en-US" sz="1200" b="1" dirty="0">
-                <a:solidFill>
-                  <a:srgbClr val="1B3A5C"/>
-                </a:solidFill>
-                <a:latin typeface="맑은 고딕" pitchFamily="34" charset="0"/>
-                <a:ea typeface="맑은 고딕" pitchFamily="34" charset="-122"/>
-                <a:cs typeface="맑은 고딕" pitchFamily="34" charset="-120"/>
-              </a:rPr>
-              <a:t>극성 성분 동반 제거</a:t>
-            </a:r>
-            <a:endParaRPr lang="en-US" sz="1200" dirty="0"/>
-          </a:p>
-        </p:txBody>
-      </p:sp>
-      <p:sp>
-        <p:nvSpPr>
-          <p:cNvPr id="22" name="Text 20"/>
-          <p:cNvSpPr/>
-          <p:nvPr/>
-        </p:nvSpPr>
-        <p:spPr>
-          <a:xfrm>
-            <a:off x="3346704" y="3511296"/>
-            <a:ext cx="2450592" cy="347472"/>
-          </a:xfrm>
-          <a:prstGeom prst="rect">
-            <a:avLst/>
-          </a:prstGeom>
-          <a:noFill/>
-          <a:ln/>
-        </p:spPr>
-        <p:txBody>
-          <a:bodyPr wrap="square" lIns="0" tIns="0" rIns="0" bIns="0" rtlCol="0" anchor="ctr"/>
-          <a:lstStyle/>
-          <a:p>
-            <a:pPr indent="0" marL="0">
-              <a:buNone/>
-            </a:pPr>
-            <a:r>
-              <a:rPr lang="en-US" sz="1050" dirty="0">
-                <a:solidFill>
-                  <a:srgbClr val="3D4A5C"/>
-                </a:solidFill>
-                <a:latin typeface="맑은 고딕" pitchFamily="34" charset="0"/>
-                <a:ea typeface="맑은 고딕" pitchFamily="34" charset="-122"/>
-                <a:cs typeface="맑은 고딕" pitchFamily="34" charset="-120"/>
-              </a:rPr>
-              <a:t>천연 윤활 성분이 같이 빠짐</a:t>
-            </a:r>
-            <a:endParaRPr lang="en-US" sz="1050" dirty="0"/>
-          </a:p>
-        </p:txBody>
-      </p:sp>
-      <p:sp>
-        <p:nvSpPr>
-          <p:cNvPr id="23" name="Text 21"/>
-          <p:cNvSpPr/>
-          <p:nvPr/>
-        </p:nvSpPr>
-        <p:spPr>
-          <a:xfrm>
-            <a:off x="822960" y="3840480"/>
-            <a:ext cx="274320" cy="182880"/>
-          </a:xfrm>
-          <a:prstGeom prst="rect">
-            <a:avLst/>
-          </a:prstGeom>
-          <a:noFill/>
-          <a:ln/>
-        </p:spPr>
-        <p:txBody>
-          <a:bodyPr wrap="square" lIns="0" tIns="0" rIns="0" bIns="0" rtlCol="0" anchor="ctr"/>
-          <a:lstStyle/>
-          <a:p>
-            <a:pPr algn="ctr" indent="0" marL="0">
-              <a:buNone/>
-            </a:pPr>
-            <a:r>
               <a:rPr lang="en-US" sz="700" dirty="0">
                 <a:solidFill>
                   <a:srgbClr val="B9C4D6"/>
@@ -17911,13 +17872,13 @@
       </p:sp>
       <p:sp>
         <p:nvSpPr>
-          <p:cNvPr id="24" name="Shape 22"/>
-          <p:cNvSpPr/>
-          <p:nvPr/>
-        </p:nvSpPr>
-        <p:spPr>
-          <a:xfrm>
-            <a:off x="822960" y="4096512"/>
+          <p:cNvPr id="23" name="Shape 21"/>
+          <p:cNvSpPr/>
+          <p:nvPr/>
+        </p:nvSpPr>
+        <p:spPr>
+          <a:xfrm>
+            <a:off x="804672" y="4169664"/>
             <a:ext cx="274320" cy="274320"/>
           </a:xfrm>
           <a:prstGeom prst="roundRect">
@@ -17938,40 +17899,79 @@
       </p:sp>
       <p:sp>
         <p:nvSpPr>
+          <p:cNvPr id="24" name="Text 22"/>
+          <p:cNvSpPr/>
+          <p:nvPr/>
+        </p:nvSpPr>
+        <p:spPr>
+          <a:xfrm>
+            <a:off x="804672" y="4169664"/>
+            <a:ext cx="274320" cy="274320"/>
+          </a:xfrm>
+          <a:prstGeom prst="rect">
+            <a:avLst/>
+          </a:prstGeom>
+          <a:noFill/>
+          <a:ln/>
+        </p:spPr>
+        <p:txBody>
+          <a:bodyPr wrap="square" lIns="0" tIns="0" rIns="0" bIns="0" rtlCol="0" anchor="ctr"/>
+          <a:lstStyle/>
+          <a:p>
+            <a:pPr algn="ctr" indent="0" marL="0">
+              <a:buNone/>
+            </a:pPr>
+            <a:r>
+              <a:rPr lang="en-US" sz="1000" b="1" dirty="0">
+                <a:solidFill>
+                  <a:srgbClr val="FFFFFF"/>
+                </a:solidFill>
+                <a:latin typeface="맑은 고딕" pitchFamily="34" charset="0"/>
+                <a:ea typeface="맑은 고딕" pitchFamily="34" charset="-122"/>
+                <a:cs typeface="맑은 고딕" pitchFamily="34" charset="-120"/>
+              </a:rPr>
+              <a:t>4</a:t>
+            </a:r>
+            <a:endParaRPr lang="en-US" sz="1000" dirty="0"/>
+          </a:p>
+        </p:txBody>
+      </p:sp>
+      <p:sp>
+        <p:nvSpPr>
           <p:cNvPr id="25" name="Text 23"/>
           <p:cNvSpPr/>
           <p:nvPr/>
         </p:nvSpPr>
         <p:spPr>
           <a:xfrm>
-            <a:off x="822960" y="4096512"/>
-            <a:ext cx="274320" cy="274320"/>
-          </a:xfrm>
-          <a:prstGeom prst="rect">
-            <a:avLst/>
-          </a:prstGeom>
-          <a:noFill/>
-          <a:ln/>
-        </p:spPr>
-        <p:txBody>
-          <a:bodyPr wrap="square" lIns="0" tIns="0" rIns="0" bIns="0" rtlCol="0" anchor="ctr"/>
-          <a:lstStyle/>
-          <a:p>
-            <a:pPr algn="ctr" indent="0" marL="0">
-              <a:buNone/>
-            </a:pPr>
-            <a:r>
-              <a:rPr lang="en-US" sz="1000" b="1" dirty="0">
-                <a:solidFill>
-                  <a:srgbClr val="FFFFFF"/>
-                </a:solidFill>
-                <a:latin typeface="맑은 고딕" pitchFamily="34" charset="0"/>
-                <a:ea typeface="맑은 고딕" pitchFamily="34" charset="-122"/>
-                <a:cs typeface="맑은 고딕" pitchFamily="34" charset="-120"/>
-              </a:rPr>
-              <a:t>4</a:t>
-            </a:r>
-            <a:endParaRPr lang="en-US" sz="1000" dirty="0"/>
+            <a:off x="1188720" y="4133088"/>
+            <a:ext cx="3456432" cy="310896"/>
+          </a:xfrm>
+          <a:prstGeom prst="rect">
+            <a:avLst/>
+          </a:prstGeom>
+          <a:noFill/>
+          <a:ln/>
+        </p:spPr>
+        <p:txBody>
+          <a:bodyPr wrap="square" lIns="0" tIns="0" rIns="0" bIns="0" rtlCol="0" anchor="ctr"/>
+          <a:lstStyle/>
+          <a:p>
+            <a:pPr indent="0" marL="0">
+              <a:buNone/>
+            </a:pPr>
+            <a:r>
+              <a:rPr lang="en-US" sz="1250" b="1" dirty="0">
+                <a:solidFill>
+                  <a:srgbClr val="C0392B"/>
+                </a:solidFill>
+                <a:latin typeface="맑은 고딕" pitchFamily="34" charset="0"/>
+                <a:ea typeface="맑은 고딕" pitchFamily="34" charset="-122"/>
+                <a:cs typeface="맑은 고딕" pitchFamily="34" charset="-120"/>
+              </a:rPr>
+              <a:t>윤활성 저하</a:t>
+            </a:r>
+            <a:endParaRPr lang="en-US" sz="1250" dirty="0"/>
           </a:p>
         </p:txBody>
       </p:sp>
@@ -17983,8 +17983,8 @@
         </p:nvSpPr>
         <p:spPr>
           <a:xfrm>
-            <a:off x="1207008" y="4059936"/>
-            <a:ext cx="2103120" cy="347472"/>
+            <a:off x="1188720" y="4425696"/>
+            <a:ext cx="3456432" cy="256032"/>
           </a:xfrm>
           <a:prstGeom prst="rect">
             <a:avLst/>
@@ -18000,45 +18000,6 @@
               <a:buNone/>
             </a:pPr>
             <a:r>
-              <a:rPr lang="en-US" sz="1200" b="1" dirty="0">
-                <a:solidFill>
-                  <a:srgbClr val="C0392B"/>
-                </a:solidFill>
-                <a:latin typeface="맑은 고딕" pitchFamily="34" charset="0"/>
-                <a:ea typeface="맑은 고딕" pitchFamily="34" charset="-122"/>
-                <a:cs typeface="맑은 고딕" pitchFamily="34" charset="-120"/>
-              </a:rPr>
-              <a:t>윤활성 저하</a:t>
-            </a:r>
-            <a:endParaRPr lang="en-US" sz="1200" dirty="0"/>
-          </a:p>
-        </p:txBody>
-      </p:sp>
-      <p:sp>
-        <p:nvSpPr>
-          <p:cNvPr id="27" name="Text 25"/>
-          <p:cNvSpPr/>
-          <p:nvPr/>
-        </p:nvSpPr>
-        <p:spPr>
-          <a:xfrm>
-            <a:off x="3346704" y="4059936"/>
-            <a:ext cx="2450592" cy="347472"/>
-          </a:xfrm>
-          <a:prstGeom prst="rect">
-            <a:avLst/>
-          </a:prstGeom>
-          <a:noFill/>
-          <a:ln/>
-        </p:spPr>
-        <p:txBody>
-          <a:bodyPr wrap="square" lIns="0" tIns="0" rIns="0" bIns="0" rtlCol="0" anchor="ctr"/>
-          <a:lstStyle/>
-          <a:p>
-            <a:pPr indent="0" marL="0">
-              <a:buNone/>
-            </a:pPr>
-            <a:r>
               <a:rPr lang="en-US" sz="1050" dirty="0">
                 <a:solidFill>
                   <a:srgbClr val="3D4A5C"/>
@@ -18055,18 +18016,18 @@
       </p:sp>
       <p:sp>
         <p:nvSpPr>
-          <p:cNvPr id="28" name="Shape 26"/>
-          <p:cNvSpPr/>
-          <p:nvPr/>
-        </p:nvSpPr>
-        <p:spPr>
-          <a:xfrm>
-            <a:off x="6345936" y="1591056"/>
-            <a:ext cx="5276088" cy="3127248"/>
+          <p:cNvPr id="27" name="Shape 25"/>
+          <p:cNvSpPr/>
+          <p:nvPr/>
+        </p:nvSpPr>
+        <p:spPr>
+          <a:xfrm>
+            <a:off x="5175504" y="1591056"/>
+            <a:ext cx="6446520" cy="3255264"/>
           </a:xfrm>
           <a:prstGeom prst="roundRect">
             <a:avLst>
-              <a:gd name="adj" fmla="val 4094"/>
+              <a:gd name="adj" fmla="val 3933"/>
             </a:avLst>
           </a:prstGeom>
           <a:solidFill>
@@ -18089,14 +18050,53 @@
       </p:sp>
       <p:sp>
         <p:nvSpPr>
+          <p:cNvPr id="28" name="Text 26"/>
+          <p:cNvSpPr/>
+          <p:nvPr/>
+        </p:nvSpPr>
+        <p:spPr>
+          <a:xfrm>
+            <a:off x="5431536" y="1792224"/>
+            <a:ext cx="5120640" cy="219456"/>
+          </a:xfrm>
+          <a:prstGeom prst="rect">
+            <a:avLst/>
+          </a:prstGeom>
+          <a:noFill/>
+          <a:ln/>
+        </p:spPr>
+        <p:txBody>
+          <a:bodyPr wrap="square" lIns="0" tIns="0" rIns="0" bIns="0" rtlCol="0" anchor="ctr"/>
+          <a:lstStyle/>
+          <a:p>
+            <a:pPr indent="0" marL="0">
+              <a:buNone/>
+            </a:pPr>
+            <a:r>
+              <a:rPr lang="en-US" sz="950" b="1" spc="180" kern="0" dirty="0">
+                <a:solidFill>
+                  <a:srgbClr val="C0392B"/>
+                </a:solidFill>
+                <a:latin typeface="맑은 고딕" pitchFamily="34" charset="0"/>
+                <a:ea typeface="맑은 고딕" pitchFamily="34" charset="-122"/>
+                <a:cs typeface="맑은 고딕" pitchFamily="34" charset="-120"/>
+              </a:rPr>
+              <a:t>IMPACT ON MACHINERY — PLUNGER &amp; INJECTOR</a:t>
+            </a:r>
+            <a:endParaRPr lang="en-US" sz="950" dirty="0"/>
+          </a:p>
+        </p:txBody>
+      </p:sp>
+      <p:sp>
+        <p:nvSpPr>
           <p:cNvPr id="29" name="Text 27"/>
           <p:cNvSpPr/>
           <p:nvPr/>
         </p:nvSpPr>
         <p:spPr>
           <a:xfrm>
-            <a:off x="6601968" y="1792224"/>
-            <a:ext cx="4206240" cy="219456"/>
+            <a:off x="5431536" y="2011680"/>
+            <a:ext cx="5934456" cy="274320"/>
           </a:xfrm>
           <a:prstGeom prst="rect">
             <a:avLst/>
@@ -18112,130 +18112,38 @@
               <a:buNone/>
             </a:pPr>
             <a:r>
-              <a:rPr lang="en-US" sz="950" b="1" spc="180" kern="0" dirty="0">
-                <a:solidFill>
-                  <a:srgbClr val="C0392B"/>
-                </a:solidFill>
-                <a:latin typeface="맑은 고딕" pitchFamily="34" charset="0"/>
-                <a:ea typeface="맑은 고딕" pitchFamily="34" charset="-122"/>
-                <a:cs typeface="맑은 고딕" pitchFamily="34" charset="-120"/>
-              </a:rPr>
-              <a:t>MEASURED RESULT — ULSD ALONE</a:t>
-            </a:r>
-            <a:endParaRPr lang="en-US" sz="950" dirty="0"/>
-          </a:p>
-        </p:txBody>
-      </p:sp>
-      <p:sp>
-        <p:nvSpPr>
-          <p:cNvPr id="30" name="Text 28"/>
-          <p:cNvSpPr/>
-          <p:nvPr/>
-        </p:nvSpPr>
-        <p:spPr>
-          <a:xfrm>
-            <a:off x="6601968" y="2048256"/>
-            <a:ext cx="4764024" cy="786384"/>
-          </a:xfrm>
-          <a:prstGeom prst="rect">
-            <a:avLst/>
-          </a:prstGeom>
-          <a:noFill/>
-          <a:ln/>
-        </p:spPr>
-        <p:txBody>
-          <a:bodyPr wrap="square" lIns="0" tIns="0" rIns="0" bIns="0" rtlCol="0" anchor="ctr"/>
-          <a:lstStyle/>
-          <a:p>
-            <a:pPr indent="0" marL="0">
-              <a:buNone/>
-            </a:pPr>
-            <a:r>
-              <a:rPr lang="en-US" sz="5200" b="1" dirty="0">
-                <a:solidFill>
-                  <a:srgbClr val="C0392B"/>
-                </a:solidFill>
-                <a:latin typeface="맑은 고딕" pitchFamily="34" charset="0"/>
-                <a:ea typeface="맑은 고딕" pitchFamily="34" charset="-122"/>
-                <a:cs typeface="맑은 고딕" pitchFamily="34" charset="-120"/>
-              </a:rPr>
-              <a:t>535</a:t>
-            </a:r>
-            <a:pPr indent="0" marL="0">
-              <a:buNone/>
-            </a:pPr>
-            <a:r>
-              <a:rPr lang="en-US" sz="1500" dirty="0">
-                <a:solidFill>
-                  <a:srgbClr val="8A94A6"/>
-                </a:solidFill>
-                <a:latin typeface="맑은 고딕" pitchFamily="34" charset="0"/>
-                <a:ea typeface="맑은 고딕" pitchFamily="34" charset="-122"/>
-                <a:cs typeface="맑은 고딕" pitchFamily="34" charset="-120"/>
-              </a:rPr>
-              <a:t> ± 50 µm</a:t>
-            </a:r>
-            <a:endParaRPr lang="en-US" sz="5200" dirty="0"/>
-          </a:p>
-        </p:txBody>
-      </p:sp>
-      <p:sp>
-        <p:nvSpPr>
-          <p:cNvPr id="31" name="Text 29"/>
-          <p:cNvSpPr/>
-          <p:nvPr/>
-        </p:nvSpPr>
-        <p:spPr>
-          <a:xfrm>
-            <a:off x="6601968" y="2816352"/>
-            <a:ext cx="4764024" cy="256032"/>
-          </a:xfrm>
-          <a:prstGeom prst="rect">
-            <a:avLst/>
-          </a:prstGeom>
-          <a:noFill/>
-          <a:ln/>
-        </p:spPr>
-        <p:txBody>
-          <a:bodyPr wrap="square" lIns="0" tIns="0" rIns="0" bIns="0" rtlCol="0" anchor="ctr"/>
-          <a:lstStyle/>
-          <a:p>
-            <a:pPr indent="0" marL="0">
-              <a:buNone/>
-            </a:pPr>
-            <a:r>
-              <a:rPr lang="en-US" sz="1100" b="1" dirty="0">
-                <a:solidFill>
-                  <a:srgbClr val="3D4A5C"/>
-                </a:solidFill>
-                <a:latin typeface="맑은 고딕" pitchFamily="34" charset="0"/>
-                <a:ea typeface="맑은 고딕" pitchFamily="34" charset="-122"/>
-                <a:cs typeface="맑은 고딕" pitchFamily="34" charset="-120"/>
-              </a:rPr>
-              <a:t>HFRR 마모흔 직경 (ISO 12156-1, WS1.4)</a:t>
-            </a:r>
-            <a:endParaRPr lang="en-US" sz="1100" dirty="0"/>
-          </a:p>
-        </p:txBody>
-      </p:sp>
-      <p:sp>
-        <p:nvSpPr>
-          <p:cNvPr id="32" name="Shape 30"/>
-          <p:cNvSpPr/>
-          <p:nvPr/>
-        </p:nvSpPr>
-        <p:spPr>
-          <a:xfrm>
-            <a:off x="6601968" y="3163824"/>
-            <a:ext cx="4764024" cy="329184"/>
+              <a:rPr lang="en-US" sz="1250" b="1" dirty="0">
+                <a:solidFill>
+                  <a:srgbClr val="1B3A5C"/>
+                </a:solidFill>
+                <a:latin typeface="맑은 고딕" pitchFamily="34" charset="0"/>
+                <a:ea typeface="맑은 고딕" pitchFamily="34" charset="-122"/>
+                <a:cs typeface="맑은 고딕" pitchFamily="34" charset="-120"/>
+              </a:rPr>
+              <a:t>윤활성을 잃은 MGO를 그대로 쓰면 금속과 금속이 직접 마찰합니다</a:t>
+            </a:r>
+            <a:endParaRPr lang="en-US" sz="1250" dirty="0"/>
+          </a:p>
+        </p:txBody>
+      </p:sp>
+      <p:sp>
+        <p:nvSpPr>
+          <p:cNvPr id="30" name="Shape 28"/>
+          <p:cNvSpPr/>
+          <p:nvPr/>
+        </p:nvSpPr>
+        <p:spPr>
+          <a:xfrm>
+            <a:off x="5431536" y="2414016"/>
+            <a:ext cx="256032" cy="256032"/>
           </a:xfrm>
           <a:prstGeom prst="roundRect">
             <a:avLst>
-              <a:gd name="adj" fmla="val 16667"/>
+              <a:gd name="adj" fmla="val 50000"/>
             </a:avLst>
           </a:prstGeom>
           <a:solidFill>
-            <a:srgbClr val="FDECEA"/>
+            <a:srgbClr val="C0392B"/>
           </a:solidFill>
           <a:ln w="12700">
             <a:solidFill>
@@ -18247,30 +18155,176 @@
       </p:sp>
       <p:sp>
         <p:nvSpPr>
+          <p:cNvPr id="31" name="Text 29"/>
+          <p:cNvSpPr/>
+          <p:nvPr/>
+        </p:nvSpPr>
+        <p:spPr>
+          <a:xfrm>
+            <a:off x="5431536" y="2414016"/>
+            <a:ext cx="256032" cy="256032"/>
+          </a:xfrm>
+          <a:prstGeom prst="rect">
+            <a:avLst/>
+          </a:prstGeom>
+          <a:noFill/>
+          <a:ln/>
+        </p:spPr>
+        <p:txBody>
+          <a:bodyPr wrap="square" lIns="0" tIns="0" rIns="0" bIns="0" rtlCol="0" anchor="ctr"/>
+          <a:lstStyle/>
+          <a:p>
+            <a:pPr algn="ctr" indent="0" marL="0">
+              <a:buNone/>
+            </a:pPr>
+            <a:r>
+              <a:rPr lang="en-US" sz="950" b="1" dirty="0">
+                <a:solidFill>
+                  <a:srgbClr val="FFFFFF"/>
+                </a:solidFill>
+                <a:latin typeface="맑은 고딕" pitchFamily="34" charset="0"/>
+                <a:ea typeface="맑은 고딕" pitchFamily="34" charset="-122"/>
+                <a:cs typeface="맑은 고딕" pitchFamily="34" charset="-120"/>
+              </a:rPr>
+              <a:t>1</a:t>
+            </a:r>
+            <a:endParaRPr lang="en-US" sz="950" dirty="0"/>
+          </a:p>
+        </p:txBody>
+      </p:sp>
+      <p:sp>
+        <p:nvSpPr>
+          <p:cNvPr id="32" name="Text 30"/>
+          <p:cNvSpPr/>
+          <p:nvPr/>
+        </p:nvSpPr>
+        <p:spPr>
+          <a:xfrm>
+            <a:off x="5779008" y="2395728"/>
+            <a:ext cx="5586984" cy="292608"/>
+          </a:xfrm>
+          <a:prstGeom prst="rect">
+            <a:avLst/>
+          </a:prstGeom>
+          <a:noFill/>
+          <a:ln/>
+        </p:spPr>
+        <p:txBody>
+          <a:bodyPr wrap="square" lIns="0" tIns="0" rIns="0" bIns="0" rtlCol="0" anchor="ctr"/>
+          <a:lstStyle/>
+          <a:p>
+            <a:pPr indent="0" marL="0">
+              <a:buNone/>
+            </a:pPr>
+            <a:r>
+              <a:rPr lang="en-US" sz="1200" b="1" dirty="0">
+                <a:solidFill>
+                  <a:srgbClr val="1B3A5C"/>
+                </a:solidFill>
+                <a:latin typeface="맑은 고딕" pitchFamily="34" charset="0"/>
+                <a:ea typeface="맑은 고딕" pitchFamily="34" charset="-122"/>
+                <a:cs typeface="맑은 고딕" pitchFamily="34" charset="-120"/>
+              </a:rPr>
+              <a:t>연료 분사 펌프 플런저 고착  </a:t>
+            </a:r>
+            <a:pPr indent="0" marL="0">
+              <a:buNone/>
+            </a:pPr>
+            <a:r>
+              <a:rPr lang="en-US" sz="950" i="1" dirty="0">
+                <a:solidFill>
+                  <a:srgbClr val="8A94A6"/>
+                </a:solidFill>
+                <a:latin typeface="맑은 고딕" pitchFamily="34" charset="0"/>
+                <a:ea typeface="맑은 고딕" pitchFamily="34" charset="-122"/>
+                <a:cs typeface="맑은 고딕" pitchFamily="34" charset="-120"/>
+              </a:rPr>
+              <a:t>Seizure</a:t>
+            </a:r>
+            <a:endParaRPr lang="en-US" sz="1200" dirty="0"/>
+          </a:p>
+        </p:txBody>
+      </p:sp>
+      <p:sp>
+        <p:nvSpPr>
           <p:cNvPr id="33" name="Text 31"/>
           <p:cNvSpPr/>
           <p:nvPr/>
         </p:nvSpPr>
         <p:spPr>
           <a:xfrm>
-            <a:off x="6729984" y="3163824"/>
-            <a:ext cx="1280160" cy="329184"/>
-          </a:xfrm>
-          <a:prstGeom prst="rect">
-            <a:avLst/>
-          </a:prstGeom>
-          <a:noFill/>
-          <a:ln/>
-        </p:spPr>
-        <p:txBody>
-          <a:bodyPr wrap="square" lIns="0" tIns="0" rIns="0" bIns="0" rtlCol="0" anchor="ctr"/>
+            <a:off x="5779008" y="2670048"/>
+            <a:ext cx="5586984" cy="457200"/>
+          </a:xfrm>
+          <a:prstGeom prst="rect">
+            <a:avLst/>
+          </a:prstGeom>
+          <a:noFill/>
+          <a:ln/>
+        </p:spPr>
+        <p:txBody>
+          <a:bodyPr wrap="square" lIns="0" tIns="0" rIns="0" bIns="0" rtlCol="0" anchor="t"/>
           <a:lstStyle/>
           <a:p>
             <a:pPr indent="0" marL="0">
-              <a:buNone/>
-            </a:pPr>
-            <a:r>
-              <a:rPr lang="en-US" sz="1050" b="1" dirty="0">
+              <a:lnSpc>
+                <a:spcPts val="1400"/>
+              </a:lnSpc>
+              <a:buNone/>
+            </a:pPr>
+            <a:r>
+              <a:rPr lang="en-US" sz="1000" dirty="0">
+                <a:solidFill>
+                  <a:srgbClr val="3D4A5C"/>
+                </a:solidFill>
+                <a:latin typeface="맑은 고딕" pitchFamily="34" charset="0"/>
+                <a:ea typeface="맑은 고딕" pitchFamily="34" charset="-122"/>
+                <a:cs typeface="맑은 고딕" pitchFamily="34" charset="-120"/>
+              </a:rPr>
+              <a:t>플런저와 배럴 사이 공차는 불과 </a:t>
+            </a:r>
+            <a:pPr indent="0" marL="0">
+              <a:lnSpc>
+                <a:spcPts val="1400"/>
+              </a:lnSpc>
+              <a:buNone/>
+            </a:pPr>
+            <a:r>
+              <a:rPr lang="en-US" sz="1000" b="1" dirty="0">
+                <a:solidFill>
+                  <a:srgbClr val="C0392B"/>
+                </a:solidFill>
+                <a:latin typeface="맑은 고딕" pitchFamily="34" charset="0"/>
+                <a:ea typeface="맑은 고딕" pitchFamily="34" charset="-122"/>
+                <a:cs typeface="맑은 고딕" pitchFamily="34" charset="-120"/>
+              </a:rPr>
+              <a:t>수 µm</a:t>
+            </a:r>
+            <a:pPr indent="0" marL="0">
+              <a:lnSpc>
+                <a:spcPts val="1400"/>
+              </a:lnSpc>
+              <a:buNone/>
+            </a:pPr>
+            <a:r>
+              <a:rPr lang="en-US" sz="1000" dirty="0">
+                <a:solidFill>
+                  <a:srgbClr val="3D4A5C"/>
+                </a:solidFill>
+                <a:latin typeface="맑은 고딕" pitchFamily="34" charset="0"/>
+                <a:ea typeface="맑은 고딕" pitchFamily="34" charset="-122"/>
+                <a:cs typeface="맑은 고딕" pitchFamily="34" charset="-120"/>
+              </a:rPr>
+              <a:t> 단위입니다. 별도 윤활유 없이 MGO 자체가 윤활제 역할을 하는데, 유막이 깨지면 금속 응착과 </a:t>
+            </a:r>
+            <a:pPr indent="0" marL="0">
+              <a:lnSpc>
+                <a:spcPts val="1400"/>
+              </a:lnSpc>
+              <a:buNone/>
+            </a:pPr>
+            <a:r>
+              <a:rPr lang="en-US" sz="1000" b="1" dirty="0">
                 <a:solidFill>
                   <a:srgbClr val="1B3A5C"/>
                 </a:solidFill>
@@ -18278,38 +18332,16 @@
                 <a:ea typeface="맑은 고딕" pitchFamily="34" charset="-122"/>
                 <a:cs typeface="맑은 고딕" pitchFamily="34" charset="-120"/>
               </a:rPr>
-              <a:t>ISO 8217</a:t>
-            </a:r>
-            <a:endParaRPr lang="en-US" sz="1050" dirty="0"/>
-          </a:p>
-        </p:txBody>
-      </p:sp>
-      <p:sp>
-        <p:nvSpPr>
-          <p:cNvPr id="34" name="Text 32"/>
-          <p:cNvSpPr/>
-          <p:nvPr/>
-        </p:nvSpPr>
-        <p:spPr>
-          <a:xfrm>
-            <a:off x="8065008" y="3163824"/>
-            <a:ext cx="1463040" cy="329184"/>
-          </a:xfrm>
-          <a:prstGeom prst="rect">
-            <a:avLst/>
-          </a:prstGeom>
-          <a:noFill/>
-          <a:ln/>
-        </p:spPr>
-        <p:txBody>
-          <a:bodyPr wrap="square" lIns="0" tIns="0" rIns="0" bIns="0" rtlCol="0" anchor="ctr"/>
-          <a:lstStyle/>
-          <a:p>
+              <a:t>스커핑(Scuffing)</a:t>
+            </a:r>
             <a:pPr indent="0" marL="0">
-              <a:buNone/>
-            </a:pPr>
-            <a:r>
-              <a:rPr lang="en-US" sz="1050" dirty="0">
+              <a:lnSpc>
+                <a:spcPts val="1400"/>
+              </a:lnSpc>
+              <a:buNone/>
+            </a:pPr>
+            <a:r>
+              <a:rPr lang="en-US" sz="1000" dirty="0">
                 <a:solidFill>
                   <a:srgbClr val="3D4A5C"/>
                 </a:solidFill>
@@ -18317,69 +18349,53 @@
                 <a:ea typeface="맑은 고딕" pitchFamily="34" charset="-122"/>
                 <a:cs typeface="맑은 고딕" pitchFamily="34" charset="-120"/>
               </a:rPr>
-              <a:t>한계 520 µm</a:t>
-            </a:r>
-            <a:endParaRPr lang="en-US" sz="1050" dirty="0"/>
-          </a:p>
-        </p:txBody>
-      </p:sp>
-      <p:sp>
-        <p:nvSpPr>
-          <p:cNvPr id="35" name="Text 33"/>
-          <p:cNvSpPr/>
-          <p:nvPr/>
-        </p:nvSpPr>
-        <p:spPr>
-          <a:xfrm>
-            <a:off x="9619488" y="3163824"/>
-            <a:ext cx="1645920" cy="329184"/>
-          </a:xfrm>
-          <a:prstGeom prst="rect">
-            <a:avLst/>
-          </a:prstGeom>
-          <a:noFill/>
-          <a:ln/>
-        </p:spPr>
-        <p:txBody>
-          <a:bodyPr wrap="square" lIns="0" tIns="0" rIns="0" bIns="0" rtlCol="0" anchor="ctr"/>
-          <a:lstStyle/>
-          <a:p>
-            <a:pPr algn="r" indent="0" marL="0">
-              <a:buNone/>
-            </a:pPr>
-            <a:r>
-              <a:rPr lang="en-US" sz="1050" b="1" dirty="0">
-                <a:solidFill>
-                  <a:srgbClr val="C0392B"/>
-                </a:solidFill>
-                <a:latin typeface="맑은 고딕" pitchFamily="34" charset="0"/>
-                <a:ea typeface="맑은 고딕" pitchFamily="34" charset="-122"/>
-                <a:cs typeface="맑은 고딕" pitchFamily="34" charset="-120"/>
-              </a:rPr>
-              <a:t>초과 — 부적합</a:t>
-            </a:r>
-            <a:endParaRPr lang="en-US" sz="1050" dirty="0"/>
-          </a:p>
-        </p:txBody>
-      </p:sp>
-      <p:sp>
-        <p:nvSpPr>
-          <p:cNvPr id="36" name="Shape 34"/>
-          <p:cNvSpPr/>
-          <p:nvPr/>
-        </p:nvSpPr>
-        <p:spPr>
-          <a:xfrm>
-            <a:off x="6601968" y="3547872"/>
-            <a:ext cx="4764024" cy="329184"/>
+              <a:t>이 일어나 펌프가 굳습니다.</a:t>
+            </a:r>
+            <a:endParaRPr lang="en-US" sz="1000" dirty="0"/>
+          </a:p>
+        </p:txBody>
+      </p:sp>
+      <p:sp>
+        <p:nvSpPr>
+          <p:cNvPr id="34" name="Shape 32"/>
+          <p:cNvSpPr/>
+          <p:nvPr/>
+        </p:nvSpPr>
+        <p:spPr>
+          <a:xfrm>
+            <a:off x="5431536" y="3145536"/>
+            <a:ext cx="5934456" cy="0"/>
+          </a:xfrm>
+          <a:prstGeom prst="line">
+            <a:avLst/>
+          </a:prstGeom>
+          <a:noFill/>
+          <a:ln w="9525">
+            <a:solidFill>
+              <a:srgbClr val="DFE5F0"/>
+            </a:solidFill>
+            <a:prstDash val="solid"/>
+          </a:ln>
+        </p:spPr>
+      </p:sp>
+      <p:sp>
+        <p:nvSpPr>
+          <p:cNvPr id="35" name="Shape 33"/>
+          <p:cNvSpPr/>
+          <p:nvPr/>
+        </p:nvSpPr>
+        <p:spPr>
+          <a:xfrm>
+            <a:off x="5431536" y="3218688"/>
+            <a:ext cx="256032" cy="256032"/>
           </a:xfrm>
           <a:prstGeom prst="roundRect">
             <a:avLst>
-              <a:gd name="adj" fmla="val 16667"/>
+              <a:gd name="adj" fmla="val 50000"/>
             </a:avLst>
           </a:prstGeom>
           <a:solidFill>
-            <a:srgbClr val="FDECEA"/>
+            <a:srgbClr val="C0392B"/>
           </a:solidFill>
           <a:ln w="12700">
             <a:solidFill>
@@ -18391,14 +18407,53 @@
       </p:sp>
       <p:sp>
         <p:nvSpPr>
+          <p:cNvPr id="36" name="Text 34"/>
+          <p:cNvSpPr/>
+          <p:nvPr/>
+        </p:nvSpPr>
+        <p:spPr>
+          <a:xfrm>
+            <a:off x="5431536" y="3218688"/>
+            <a:ext cx="256032" cy="256032"/>
+          </a:xfrm>
+          <a:prstGeom prst="rect">
+            <a:avLst/>
+          </a:prstGeom>
+          <a:noFill/>
+          <a:ln/>
+        </p:spPr>
+        <p:txBody>
+          <a:bodyPr wrap="square" lIns="0" tIns="0" rIns="0" bIns="0" rtlCol="0" anchor="ctr"/>
+          <a:lstStyle/>
+          <a:p>
+            <a:pPr algn="ctr" indent="0" marL="0">
+              <a:buNone/>
+            </a:pPr>
+            <a:r>
+              <a:rPr lang="en-US" sz="950" b="1" dirty="0">
+                <a:solidFill>
+                  <a:srgbClr val="FFFFFF"/>
+                </a:solidFill>
+                <a:latin typeface="맑은 고딕" pitchFamily="34" charset="0"/>
+                <a:ea typeface="맑은 고딕" pitchFamily="34" charset="-122"/>
+                <a:cs typeface="맑은 고딕" pitchFamily="34" charset="-120"/>
+              </a:rPr>
+              <a:t>2</a:t>
+            </a:r>
+            <a:endParaRPr lang="en-US" sz="950" dirty="0"/>
+          </a:p>
+        </p:txBody>
+      </p:sp>
+      <p:sp>
+        <p:nvSpPr>
           <p:cNvPr id="37" name="Text 35"/>
           <p:cNvSpPr/>
           <p:nvPr/>
         </p:nvSpPr>
         <p:spPr>
           <a:xfrm>
-            <a:off x="6729984" y="3547872"/>
-            <a:ext cx="1280160" cy="329184"/>
+            <a:off x="5779008" y="3200400"/>
+            <a:ext cx="5586984" cy="292608"/>
           </a:xfrm>
           <a:prstGeom prst="rect">
             <a:avLst/>
@@ -18414,7 +18469,7 @@
               <a:buNone/>
             </a:pPr>
             <a:r>
-              <a:rPr lang="en-US" sz="1050" b="1" dirty="0">
+              <a:rPr lang="en-US" sz="1200" b="1" dirty="0">
                 <a:solidFill>
                   <a:srgbClr val="1B3A5C"/>
                 </a:solidFill>
@@ -18422,9 +18477,23 @@
                 <a:ea typeface="맑은 고딕" pitchFamily="34" charset="-122"/>
                 <a:cs typeface="맑은 고딕" pitchFamily="34" charset="-120"/>
               </a:rPr>
-              <a:t>EN 590</a:t>
-            </a:r>
-            <a:endParaRPr lang="en-US" sz="1050" dirty="0"/>
+              <a:t>인젝터 노즐 마모 및 누설  </a:t>
+            </a:r>
+            <a:pPr indent="0" marL="0">
+              <a:buNone/>
+            </a:pPr>
+            <a:r>
+              <a:rPr lang="en-US" sz="950" i="1" dirty="0">
+                <a:solidFill>
+                  <a:srgbClr val="8A94A6"/>
+                </a:solidFill>
+                <a:latin typeface="맑은 고딕" pitchFamily="34" charset="0"/>
+                <a:ea typeface="맑은 고딕" pitchFamily="34" charset="-122"/>
+                <a:cs typeface="맑은 고딕" pitchFamily="34" charset="-120"/>
+              </a:rPr>
+              <a:t>Leakage</a:t>
+            </a:r>
+            <a:endParaRPr lang="en-US" sz="1200" dirty="0"/>
           </a:p>
         </p:txBody>
       </p:sp>
@@ -18436,105 +18505,203 @@
         </p:nvSpPr>
         <p:spPr>
           <a:xfrm>
-            <a:off x="8065008" y="3547872"/>
-            <a:ext cx="1463040" cy="329184"/>
-          </a:xfrm>
-          <a:prstGeom prst="rect">
-            <a:avLst/>
-          </a:prstGeom>
-          <a:noFill/>
-          <a:ln/>
-        </p:spPr>
-        <p:txBody>
-          <a:bodyPr wrap="square" lIns="0" tIns="0" rIns="0" bIns="0" rtlCol="0" anchor="ctr"/>
-          <a:lstStyle/>
-          <a:p>
-            <a:pPr indent="0" marL="0">
-              <a:buNone/>
-            </a:pPr>
-            <a:r>
-              <a:rPr lang="en-US" sz="1050" dirty="0">
-                <a:solidFill>
-                  <a:srgbClr val="3D4A5C"/>
-                </a:solidFill>
-                <a:latin typeface="맑은 고딕" pitchFamily="34" charset="0"/>
-                <a:ea typeface="맑은 고딕" pitchFamily="34" charset="-122"/>
-                <a:cs typeface="맑은 고딕" pitchFamily="34" charset="-120"/>
-              </a:rPr>
-              <a:t>한계 460 µm</a:t>
-            </a:r>
-            <a:endParaRPr lang="en-US" sz="1050" dirty="0"/>
-          </a:p>
-        </p:txBody>
-      </p:sp>
-      <p:sp>
-        <p:nvSpPr>
-          <p:cNvPr id="39" name="Text 37"/>
-          <p:cNvSpPr/>
-          <p:nvPr/>
-        </p:nvSpPr>
-        <p:spPr>
-          <a:xfrm>
-            <a:off x="9619488" y="3547872"/>
-            <a:ext cx="1645920" cy="329184"/>
-          </a:xfrm>
-          <a:prstGeom prst="rect">
-            <a:avLst/>
-          </a:prstGeom>
-          <a:noFill/>
-          <a:ln/>
-        </p:spPr>
-        <p:txBody>
-          <a:bodyPr wrap="square" lIns="0" tIns="0" rIns="0" bIns="0" rtlCol="0" anchor="ctr"/>
-          <a:lstStyle/>
-          <a:p>
-            <a:pPr algn="r" indent="0" marL="0">
-              <a:buNone/>
-            </a:pPr>
-            <a:r>
-              <a:rPr lang="en-US" sz="1050" b="1" dirty="0">
-                <a:solidFill>
-                  <a:srgbClr val="C0392B"/>
-                </a:solidFill>
-                <a:latin typeface="맑은 고딕" pitchFamily="34" charset="0"/>
-                <a:ea typeface="맑은 고딕" pitchFamily="34" charset="-122"/>
-                <a:cs typeface="맑은 고딕" pitchFamily="34" charset="-120"/>
-              </a:rPr>
-              <a:t>초과 — 부적합</a:t>
-            </a:r>
-            <a:endParaRPr lang="en-US" sz="1050" dirty="0"/>
-          </a:p>
-        </p:txBody>
-      </p:sp>
-      <p:sp>
-        <p:nvSpPr>
-          <p:cNvPr id="40" name="Text 38"/>
-          <p:cNvSpPr/>
-          <p:nvPr/>
-        </p:nvSpPr>
-        <p:spPr>
-          <a:xfrm>
-            <a:off x="6601968" y="3986784"/>
-            <a:ext cx="4764024" cy="512064"/>
-          </a:xfrm>
-          <a:prstGeom prst="rect">
-            <a:avLst/>
-          </a:prstGeom>
-          <a:noFill/>
-          <a:ln/>
-        </p:spPr>
-        <p:txBody>
-          <a:bodyPr wrap="square" lIns="0" tIns="0" rIns="0" bIns="0" rtlCol="0" anchor="ctr"/>
+            <a:off x="5779008" y="3474720"/>
+            <a:ext cx="5586984" cy="457200"/>
+          </a:xfrm>
+          <a:prstGeom prst="rect">
+            <a:avLst/>
+          </a:prstGeom>
+          <a:noFill/>
+          <a:ln/>
+        </p:spPr>
+        <p:txBody>
+          <a:bodyPr wrap="square" lIns="0" tIns="0" rIns="0" bIns="0" rtlCol="0" anchor="t"/>
           <a:lstStyle/>
           <a:p>
             <a:pPr indent="0" marL="0">
               <a:lnSpc>
-                <a:spcPts val="1500"/>
+                <a:spcPts val="1400"/>
               </a:lnSpc>
               <a:buNone/>
             </a:pPr>
             <a:r>
-              <a:rPr lang="en-US" sz="1000" i="1" dirty="0">
+              <a:rPr lang="en-US" sz="1000" dirty="0">
+                <a:solidFill>
+                  <a:srgbClr val="3D4A5C"/>
+                </a:solidFill>
+                <a:latin typeface="맑은 고딕" pitchFamily="34" charset="0"/>
+                <a:ea typeface="맑은 고딕" pitchFamily="34" charset="-122"/>
+                <a:cs typeface="맑은 고딕" pitchFamily="34" charset="-120"/>
+              </a:rPr>
+              <a:t>고압으로 작동하는 니들 밸브가 마모되어 기밀을 잃습니다. </a:t>
+            </a:r>
+            <a:pPr indent="0" marL="0">
+              <a:lnSpc>
+                <a:spcPts val="1400"/>
+              </a:lnSpc>
+              <a:buNone/>
+            </a:pPr>
+            <a:r>
+              <a:rPr lang="en-US" sz="1000" b="1" dirty="0">
+                <a:solidFill>
+                  <a:srgbClr val="1B3A5C"/>
+                </a:solidFill>
+                <a:latin typeface="맑은 고딕" pitchFamily="34" charset="0"/>
+                <a:ea typeface="맑은 고딕" pitchFamily="34" charset="-122"/>
+                <a:cs typeface="맑은 고딕" pitchFamily="34" charset="-120"/>
+              </a:rPr>
+              <a:t>분사 패턴(Atomization)</a:t>
+            </a:r>
+            <a:pPr indent="0" marL="0">
+              <a:lnSpc>
+                <a:spcPts val="1400"/>
+              </a:lnSpc>
+              <a:buNone/>
+            </a:pPr>
+            <a:r>
+              <a:rPr lang="en-US" sz="1000" dirty="0">
+                <a:solidFill>
+                  <a:srgbClr val="3D4A5C"/>
+                </a:solidFill>
+                <a:latin typeface="맑은 고딕" pitchFamily="34" charset="0"/>
+                <a:ea typeface="맑은 고딕" pitchFamily="34" charset="-122"/>
+                <a:cs typeface="맑은 고딕" pitchFamily="34" charset="-120"/>
+              </a:rPr>
+              <a:t>이 무너져 불완전 연소와 스모크로 이어집니다.</a:t>
+            </a:r>
+            <a:endParaRPr lang="en-US" sz="1000" dirty="0"/>
+          </a:p>
+        </p:txBody>
+      </p:sp>
+      <p:sp>
+        <p:nvSpPr>
+          <p:cNvPr id="39" name="Shape 37"/>
+          <p:cNvSpPr/>
+          <p:nvPr/>
+        </p:nvSpPr>
+        <p:spPr>
+          <a:xfrm>
+            <a:off x="5431536" y="3950208"/>
+            <a:ext cx="5934456" cy="0"/>
+          </a:xfrm>
+          <a:prstGeom prst="line">
+            <a:avLst/>
+          </a:prstGeom>
+          <a:noFill/>
+          <a:ln w="9525">
+            <a:solidFill>
+              <a:srgbClr val="DFE5F0"/>
+            </a:solidFill>
+            <a:prstDash val="solid"/>
+          </a:ln>
+        </p:spPr>
+      </p:sp>
+      <p:sp>
+        <p:nvSpPr>
+          <p:cNvPr id="40" name="Shape 38"/>
+          <p:cNvSpPr/>
+          <p:nvPr/>
+        </p:nvSpPr>
+        <p:spPr>
+          <a:xfrm>
+            <a:off x="5431536" y="4023360"/>
+            <a:ext cx="256032" cy="256032"/>
+          </a:xfrm>
+          <a:prstGeom prst="roundRect">
+            <a:avLst>
+              <a:gd name="adj" fmla="val 50000"/>
+            </a:avLst>
+          </a:prstGeom>
+          <a:solidFill>
+            <a:srgbClr val="C0392B"/>
+          </a:solidFill>
+          <a:ln w="12700">
+            <a:solidFill>
+              <a:srgbClr val="333333"/>
+            </a:solidFill>
+            <a:prstDash val="solid"/>
+          </a:ln>
+        </p:spPr>
+      </p:sp>
+      <p:sp>
+        <p:nvSpPr>
+          <p:cNvPr id="41" name="Text 39"/>
+          <p:cNvSpPr/>
+          <p:nvPr/>
+        </p:nvSpPr>
+        <p:spPr>
+          <a:xfrm>
+            <a:off x="5431536" y="4023360"/>
+            <a:ext cx="256032" cy="256032"/>
+          </a:xfrm>
+          <a:prstGeom prst="rect">
+            <a:avLst/>
+          </a:prstGeom>
+          <a:noFill/>
+          <a:ln/>
+        </p:spPr>
+        <p:txBody>
+          <a:bodyPr wrap="square" lIns="0" tIns="0" rIns="0" bIns="0" rtlCol="0" anchor="ctr"/>
+          <a:lstStyle/>
+          <a:p>
+            <a:pPr algn="ctr" indent="0" marL="0">
+              <a:buNone/>
+            </a:pPr>
+            <a:r>
+              <a:rPr lang="en-US" sz="950" b="1" dirty="0">
+                <a:solidFill>
+                  <a:srgbClr val="FFFFFF"/>
+                </a:solidFill>
+                <a:latin typeface="맑은 고딕" pitchFamily="34" charset="0"/>
+                <a:ea typeface="맑은 고딕" pitchFamily="34" charset="-122"/>
+                <a:cs typeface="맑은 고딕" pitchFamily="34" charset="-120"/>
+              </a:rPr>
+              <a:t>3</a:t>
+            </a:r>
+            <a:endParaRPr lang="en-US" sz="950" dirty="0"/>
+          </a:p>
+        </p:txBody>
+      </p:sp>
+      <p:sp>
+        <p:nvSpPr>
+          <p:cNvPr id="42" name="Text 40"/>
+          <p:cNvSpPr/>
+          <p:nvPr/>
+        </p:nvSpPr>
+        <p:spPr>
+          <a:xfrm>
+            <a:off x="5779008" y="4005072"/>
+            <a:ext cx="5586984" cy="292608"/>
+          </a:xfrm>
+          <a:prstGeom prst="rect">
+            <a:avLst/>
+          </a:prstGeom>
+          <a:noFill/>
+          <a:ln/>
+        </p:spPr>
+        <p:txBody>
+          <a:bodyPr wrap="square" lIns="0" tIns="0" rIns="0" bIns="0" rtlCol="0" anchor="ctr"/>
+          <a:lstStyle/>
+          <a:p>
+            <a:pPr indent="0" marL="0">
+              <a:buNone/>
+            </a:pPr>
+            <a:r>
+              <a:rPr lang="en-US" sz="1200" b="1" dirty="0">
+                <a:solidFill>
+                  <a:srgbClr val="1B3A5C"/>
+                </a:solidFill>
+                <a:latin typeface="맑은 고딕" pitchFamily="34" charset="0"/>
+                <a:ea typeface="맑은 고딕" pitchFamily="34" charset="-122"/>
+                <a:cs typeface="맑은 고딕" pitchFamily="34" charset="-120"/>
+              </a:rPr>
+              <a:t>HFRR 마모흔 직경 초과  </a:t>
+            </a:r>
+            <a:pPr indent="0" marL="0">
+              <a:buNone/>
+            </a:pPr>
+            <a:r>
+              <a:rPr lang="en-US" sz="950" i="1" dirty="0">
                 <a:solidFill>
                   <a:srgbClr val="8A94A6"/>
                 </a:solidFill>
@@ -18542,7 +18709,117 @@
                 <a:ea typeface="맑은 고딕" pitchFamily="34" charset="-122"/>
                 <a:cs typeface="맑은 고딕" pitchFamily="34" charset="-120"/>
               </a:rPr>
-              <a:t>손상 부위: 연료펌프 플런저 · 인젝터 — Section 01 슬라이드 03의 New Orleans 사례와 같은 부위입니다.</a:t>
+              <a:t>ISO 12156-1</a:t>
+            </a:r>
+            <a:endParaRPr lang="en-US" sz="1200" dirty="0"/>
+          </a:p>
+        </p:txBody>
+      </p:sp>
+      <p:sp>
+        <p:nvSpPr>
+          <p:cNvPr id="43" name="Text 41"/>
+          <p:cNvSpPr/>
+          <p:nvPr/>
+        </p:nvSpPr>
+        <p:spPr>
+          <a:xfrm>
+            <a:off x="5779008" y="4279392"/>
+            <a:ext cx="5586984" cy="457200"/>
+          </a:xfrm>
+          <a:prstGeom prst="rect">
+            <a:avLst/>
+          </a:prstGeom>
+          <a:noFill/>
+          <a:ln/>
+        </p:spPr>
+        <p:txBody>
+          <a:bodyPr wrap="square" lIns="0" tIns="0" rIns="0" bIns="0" rtlCol="0" anchor="t"/>
+          <a:lstStyle/>
+          <a:p>
+            <a:pPr indent="0" marL="0">
+              <a:lnSpc>
+                <a:spcPts val="1400"/>
+              </a:lnSpc>
+              <a:buNone/>
+            </a:pPr>
+            <a:r>
+              <a:rPr lang="en-US" sz="1000" dirty="0">
+                <a:solidFill>
+                  <a:srgbClr val="3D4A5C"/>
+                </a:solidFill>
+                <a:latin typeface="맑은 고딕" pitchFamily="34" charset="0"/>
+                <a:ea typeface="맑은 고딕" pitchFamily="34" charset="-122"/>
+                <a:cs typeface="맑은 고딕" pitchFamily="34" charset="-120"/>
+              </a:rPr>
+              <a:t>ISO 12156-1 윤활성 시험에서 </a:t>
+            </a:r>
+            <a:pPr indent="0" marL="0">
+              <a:lnSpc>
+                <a:spcPts val="1400"/>
+              </a:lnSpc>
+              <a:buNone/>
+            </a:pPr>
+            <a:r>
+              <a:rPr lang="en-US" sz="1000" b="1" dirty="0">
+                <a:solidFill>
+                  <a:srgbClr val="C0392B"/>
+                </a:solidFill>
+                <a:latin typeface="맑은 고딕" pitchFamily="34" charset="0"/>
+                <a:ea typeface="맑은 고딕" pitchFamily="34" charset="-122"/>
+                <a:cs typeface="맑은 고딕" pitchFamily="34" charset="-120"/>
+              </a:rPr>
+              <a:t>535 µm</a:t>
+            </a:r>
+            <a:pPr indent="0" marL="0">
+              <a:lnSpc>
+                <a:spcPts val="1400"/>
+              </a:lnSpc>
+              <a:buNone/>
+            </a:pPr>
+            <a:r>
+              <a:rPr lang="en-US" sz="1000" dirty="0">
+                <a:solidFill>
+                  <a:srgbClr val="3D4A5C"/>
+                </a:solidFill>
+                <a:latin typeface="맑은 고딕" pitchFamily="34" charset="0"/>
+                <a:ea typeface="맑은 고딕" pitchFamily="34" charset="-122"/>
+                <a:cs typeface="맑은 고딕" pitchFamily="34" charset="-120"/>
+              </a:rPr>
+              <a:t> 측정 — ISO 8217 한계 520 µm, EN 590 한계 460 µm를 </a:t>
+            </a:r>
+            <a:pPr indent="0" marL="0">
+              <a:lnSpc>
+                <a:spcPts val="1400"/>
+              </a:lnSpc>
+              <a:buNone/>
+            </a:pPr>
+            <a:r>
+              <a:rPr lang="en-US" sz="1000" b="1" dirty="0">
+                <a:solidFill>
+                  <a:srgbClr val="C0392B"/>
+                </a:solidFill>
+                <a:latin typeface="맑은 고딕" pitchFamily="34" charset="0"/>
+                <a:ea typeface="맑은 고딕" pitchFamily="34" charset="-122"/>
+                <a:cs typeface="맑은 고딕" pitchFamily="34" charset="-120"/>
+              </a:rPr>
+              <a:t>모두 초과</a:t>
+            </a:r>
+            <a:pPr indent="0" marL="0">
+              <a:lnSpc>
+                <a:spcPts val="1400"/>
+              </a:lnSpc>
+              <a:buNone/>
+            </a:pPr>
+            <a:r>
+              <a:rPr lang="en-US" sz="1000" dirty="0">
+                <a:solidFill>
+                  <a:srgbClr val="3D4A5C"/>
+                </a:solidFill>
+                <a:latin typeface="맑은 고딕" pitchFamily="34" charset="0"/>
+                <a:ea typeface="맑은 고딕" pitchFamily="34" charset="-122"/>
+                <a:cs typeface="맑은 고딕" pitchFamily="34" charset="-120"/>
+              </a:rPr>
+              <a:t>합니다.</a:t>
             </a:r>
             <a:endParaRPr lang="en-US" sz="1000" dirty="0"/>
           </a:p>
@@ -18550,13 +18827,13 @@
       </p:sp>
       <p:sp>
         <p:nvSpPr>
-          <p:cNvPr id="41" name="Shape 39"/>
-          <p:cNvSpPr/>
-          <p:nvPr/>
-        </p:nvSpPr>
-        <p:spPr>
-          <a:xfrm>
-            <a:off x="566928" y="4901184"/>
+          <p:cNvPr id="44" name="Shape 42"/>
+          <p:cNvSpPr/>
+          <p:nvPr/>
+        </p:nvSpPr>
+        <p:spPr>
+          <a:xfrm>
+            <a:off x="566928" y="5010912"/>
             <a:ext cx="11057839" cy="786384"/>
           </a:xfrm>
           <a:prstGeom prst="roundRect">
@@ -18577,13 +18854,13 @@
       </p:sp>
       <p:sp>
         <p:nvSpPr>
-          <p:cNvPr id="42" name="Text 40"/>
-          <p:cNvSpPr/>
-          <p:nvPr/>
-        </p:nvSpPr>
-        <p:spPr>
-          <a:xfrm>
-            <a:off x="795528" y="4901184"/>
+          <p:cNvPr id="45" name="Text 43"/>
+          <p:cNvSpPr/>
+          <p:nvPr/>
+        </p:nvSpPr>
+        <p:spPr>
+          <a:xfrm>
+            <a:off x="795528" y="5010912"/>
             <a:ext cx="10600639" cy="786384"/>
           </a:xfrm>
           <a:prstGeom prst="rect">
@@ -18644,13 +18921,13 @@
       </p:sp>
       <p:sp>
         <p:nvSpPr>
-          <p:cNvPr id="43" name="Text 41"/>
-          <p:cNvSpPr/>
-          <p:nvPr/>
-        </p:nvSpPr>
-        <p:spPr>
-          <a:xfrm>
-            <a:off x="566928" y="5815584"/>
+          <p:cNvPr id="46" name="Text 44"/>
+          <p:cNvSpPr/>
+          <p:nvPr/>
+        </p:nvSpPr>
+        <p:spPr>
+          <a:xfrm>
+            <a:off x="566928" y="5925312"/>
             <a:ext cx="11057839" cy="219456"/>
           </a:xfrm>
           <a:prstGeom prst="rect">

</xml_diff>

<commit_message>
Clarify what the HFRR wear scar number is and is not
The wear scar diameter reads as a dimension next to a plunger-barrel
clearance of a few microns, which invites the objection that a 180 um
reduction cannot matter. It is neither a depth nor a clearance: it is
the diameter of the flat worn onto a 6 mm test ball, and the spec
limits come from field failure history rather than from any geometry.

Adds that caveat to the slide, reframes the results banner around
crossing the limit rather than the size of the reduction, and puts the
full rebuttal in the speaker notes so the presenter can answer it live.

Co-Authored-By: Claude Opus 5 <noreply@anthropic.com>
Claude-Session: https://claude.ai/code/session_0181AXsH7YB1d1u5cHBfg2wM
</commit_message>
<xml_diff>
--- a/deck/fuel_training_deck.pptx
+++ b/deck/fuel_training_deck.pptx
@@ -1692,7 +1692,13 @@
           <a:p>
             <a:r>
               <a:rPr lang="en-US" dirty="0"/>
-              <a:t>왼쪽은 왜 이런 일이 생기는지, 오른쪽은 그래서 본선에서 무엇이 망가지는지입니다. 세 번째 항목이 앞의 두 가지를 숫자로 확인해 주는 구조입니다. 플런저-배럴 공차가 수 마이크론이라는 점을 강조하십시오 — 유막 두께가 그보다 얇아지는 순간 바로 금속끼리 닿습니다. 그리고 이 ULSD는 다른 ISO 항목은 전부 만족한 정상 연료입니다. 슬라이드 03의 착시와 같은 구조이고, 원심분리기로는 535 µm를 단 1 µm도 낮출 수 없습니다.</a:t>
+              <a:t>왼쪽은 왜 이런 일이 생기는지, 오른쪽은 그래서 본선에서 무엇이 망가지는지입니다. 플런저-배럴 공차가 수 마이크론이라는 점을 강조하십시오 — 유막이 그보다 얇아지는 순간 금속끼리 닿습니다.
+[예상 질문] "공차가 수 µm인데 535 µm니 355 µm니 하는 게 무슨 의미가 있나?"
+— 아주 좋은 질문이고 반드시 나옵니다. 답은 세 가지입니다.
+1) 535 µm는 깊이도 틈새도 아닙니다. ISO 12156-1은 지름 6 mm 강구를 연료 속에서 강판에 60°C·200 g·50 Hz로 75분 문지른 뒤, 볼에 생긴 자국의 지름을 재는 시험입니다. 6,000 µm 볼에 생긴 535 µm 자국이니 볼 지름의 9% 수준입니다. 펌프 안에 535 µm짜리 치수는 없습니다. 참고로 구면 기하로 깊이를 환산하면 535 µm는 약 12 µm, 355 µm는 약 5 µm입니다 — 공차와 같은 자릿수입니다.
+2) 더 중요한 것은 이 값이 치수가 아니라 지표라는 점입니다. 펌프 안에서 실제로 문제되는 것은 유막 두께 대 표면 거칠기이고, 둘 다 서브미크론입니다. HFRR은 그 유막을 연료가 만들어낼 수 있는지를 잽니다. '당신 펌프가 535 µm 닳는다'가 아니라 '이 연료는 보호막을 못 만든다'는 뜻입니다.
+3) 520·460이라는 한계선은 공차에서 유도한 값이 아니라 실제 고장 이력에서 나온 값입니다. 연료분사장비 제조사들이 그 위에서 고장이 급증한다는 이유로 460 µm를 권고했고, ISO 8217은 선박용 증류유 기준으로 520 µm를 채택했습니다. 따라서 535 → 355의 의미는 '마모가 180 µm 줄었다'가 아니라 '고장이 몰려 있던 구간 밖으로 나왔다'입니다.
+덧붙여, 이 ULSD는 다른 ISO 항목은 전부 만족한 정상 연료입니다. 슬라이드 03의 착시와 같은 구조이고, 원심분리기로는 535 µm를 단 1 µm도 낮출 수 없습니다.</a:t>
             </a:r>
             <a:endParaRPr lang="en-US" dirty="0"/>
           </a:p>
@@ -1780,7 +1786,10 @@
           <a:p>
             <a:r>
               <a:rPr lang="en-US" dirty="0"/>
-              <a:t>막대 세 개가 전부입니다. 무처리 ULSD는 535 µm로 ISO 8217 520을 넘겨 부적합입니다. 100 ppm에서 396, 150 ppm에서 355로 떨어지고 두 규격 모두 통과합니다. 150 ppm 기준 33.6% 개선인데, 이 수치는 Lloyd's Register Product Verification Scheme 인증으로 공표된 34%와 일치합니다. 재질 주의는 실무에서 중요합니다 — 투입 계통의 씰과 개스킷 재질을 먼저 확인해야 합니다.</a:t>
+              <a:t>막대 세 개가 전부입니다. 무처리 ULSD는 535 µm로 ISO 8217 520을 넘겨 부적합입니다. 100 ppm에서 396, 150 ppm에서 355로 떨어지고 두 규격 모두 통과합니다.
+여기서 말을 정확히 하십시오. 이 시험은 연속적으로 좋아지는 양을 보여주는 것이 아니라 합격선을 넘느냐 마느냐를 보여줍니다. 355와 396의 41 µm 차이가 펌프 수명 차이로 직결된다고 말하면 과장입니다. 핵심은 두 값 모두 고장이 몰려 있던 구간 밖에 있다는 것입니다.
+150 ppm 기준 감소율은 33.6%이고, 이 수치는 Lloyd's Register Product Verification Scheme 인증으로 공표된 34%와 일치합니다 — 사내 시험과 제3자 인증이 서로를 뒷받침합니다.
+재질 주의는 실무에서 중요합니다. 투입 계통의 씰과 개스킷 재질을 먼저 확인해야 합니다.</a:t>
             </a:r>
             <a:endParaRPr lang="en-US" dirty="0"/>
           </a:p>
@@ -17257,11 +17266,11 @@
         <p:spPr>
           <a:xfrm>
             <a:off x="566928" y="1591056"/>
-            <a:ext cx="4315968" cy="3255264"/>
+            <a:ext cx="4315968" cy="3346704"/>
           </a:xfrm>
           <a:prstGeom prst="roundRect">
             <a:avLst>
-              <a:gd name="adj" fmla="val 3933"/>
+              <a:gd name="adj" fmla="val 3825"/>
             </a:avLst>
           </a:prstGeom>
           <a:solidFill>
@@ -18023,11 +18032,11 @@
         <p:spPr>
           <a:xfrm>
             <a:off x="5175504" y="1591056"/>
-            <a:ext cx="6446520" cy="3255264"/>
+            <a:ext cx="6446520" cy="3346704"/>
           </a:xfrm>
           <a:prstGeom prst="roundRect">
             <a:avLst>
-              <a:gd name="adj" fmla="val 3933"/>
+              <a:gd name="adj" fmla="val 3825"/>
             </a:avLst>
           </a:prstGeom>
           <a:solidFill>
@@ -18134,7 +18143,7 @@
         </p:nvSpPr>
         <p:spPr>
           <a:xfrm>
-            <a:off x="5431536" y="2414016"/>
+            <a:off x="5431536" y="2395728"/>
             <a:ext cx="256032" cy="256032"/>
           </a:xfrm>
           <a:prstGeom prst="roundRect">
@@ -18161,7 +18170,7 @@
         </p:nvSpPr>
         <p:spPr>
           <a:xfrm>
-            <a:off x="5431536" y="2414016"/>
+            <a:off x="5431536" y="2395728"/>
             <a:ext cx="256032" cy="256032"/>
           </a:xfrm>
           <a:prstGeom prst="rect">
@@ -18200,7 +18209,7 @@
         </p:nvSpPr>
         <p:spPr>
           <a:xfrm>
-            <a:off x="5779008" y="2395728"/>
+            <a:off x="5779008" y="2377440"/>
             <a:ext cx="5586984" cy="292608"/>
           </a:xfrm>
           <a:prstGeom prst="rect">
@@ -18253,8 +18262,8 @@
         </p:nvSpPr>
         <p:spPr>
           <a:xfrm>
-            <a:off x="5779008" y="2670048"/>
-            <a:ext cx="5586984" cy="457200"/>
+            <a:off x="5779008" y="2651760"/>
+            <a:ext cx="5586984" cy="402336"/>
           </a:xfrm>
           <a:prstGeom prst="rect">
             <a:avLst/>
@@ -18363,7 +18372,7 @@
         </p:nvSpPr>
         <p:spPr>
           <a:xfrm>
-            <a:off x="5431536" y="3145536"/>
+            <a:off x="5431536" y="3072384"/>
             <a:ext cx="5934456" cy="0"/>
           </a:xfrm>
           <a:prstGeom prst="line">
@@ -18386,7 +18395,7 @@
         </p:nvSpPr>
         <p:spPr>
           <a:xfrm>
-            <a:off x="5431536" y="3218688"/>
+            <a:off x="5431536" y="3145536"/>
             <a:ext cx="256032" cy="256032"/>
           </a:xfrm>
           <a:prstGeom prst="roundRect">
@@ -18413,7 +18422,7 @@
         </p:nvSpPr>
         <p:spPr>
           <a:xfrm>
-            <a:off x="5431536" y="3218688"/>
+            <a:off x="5431536" y="3145536"/>
             <a:ext cx="256032" cy="256032"/>
           </a:xfrm>
           <a:prstGeom prst="rect">
@@ -18452,7 +18461,7 @@
         </p:nvSpPr>
         <p:spPr>
           <a:xfrm>
-            <a:off x="5779008" y="3200400"/>
+            <a:off x="5779008" y="3127248"/>
             <a:ext cx="5586984" cy="292608"/>
           </a:xfrm>
           <a:prstGeom prst="rect">
@@ -18505,8 +18514,8 @@
         </p:nvSpPr>
         <p:spPr>
           <a:xfrm>
-            <a:off x="5779008" y="3474720"/>
-            <a:ext cx="5586984" cy="457200"/>
+            <a:off x="5779008" y="3401568"/>
+            <a:ext cx="5586984" cy="402336"/>
           </a:xfrm>
           <a:prstGeom prst="rect">
             <a:avLst/>
@@ -18581,7 +18590,7 @@
         </p:nvSpPr>
         <p:spPr>
           <a:xfrm>
-            <a:off x="5431536" y="3950208"/>
+            <a:off x="5431536" y="3822192"/>
             <a:ext cx="5934456" cy="0"/>
           </a:xfrm>
           <a:prstGeom prst="line">
@@ -18604,7 +18613,7 @@
         </p:nvSpPr>
         <p:spPr>
           <a:xfrm>
-            <a:off x="5431536" y="4023360"/>
+            <a:off x="5431536" y="3895344"/>
             <a:ext cx="256032" cy="256032"/>
           </a:xfrm>
           <a:prstGeom prst="roundRect">
@@ -18631,7 +18640,7 @@
         </p:nvSpPr>
         <p:spPr>
           <a:xfrm>
-            <a:off x="5431536" y="4023360"/>
+            <a:off x="5431536" y="3895344"/>
             <a:ext cx="256032" cy="256032"/>
           </a:xfrm>
           <a:prstGeom prst="rect">
@@ -18670,7 +18679,7 @@
         </p:nvSpPr>
         <p:spPr>
           <a:xfrm>
-            <a:off x="5779008" y="4005072"/>
+            <a:off x="5779008" y="3877056"/>
             <a:ext cx="5586984" cy="292608"/>
           </a:xfrm>
           <a:prstGeom prst="rect">
@@ -18723,8 +18732,8 @@
         </p:nvSpPr>
         <p:spPr>
           <a:xfrm>
-            <a:off x="5779008" y="4279392"/>
-            <a:ext cx="5586984" cy="457200"/>
+            <a:off x="5779008" y="4151376"/>
+            <a:ext cx="5586984" cy="402336"/>
           </a:xfrm>
           <a:prstGeom prst="rect">
             <a:avLst/>
@@ -18751,7 +18760,7 @@
                 <a:ea typeface="맑은 고딕" pitchFamily="34" charset="-122"/>
                 <a:cs typeface="맑은 고딕" pitchFamily="34" charset="-120"/>
               </a:rPr>
-              <a:t>ISO 12156-1 윤활성 시험에서 </a:t>
+              <a:t>연료가 보호막을 만들지 못한다는 지표입니다. </a:t>
             </a:r>
             <a:pPr indent="0" marL="0">
               <a:lnSpc>
@@ -18785,7 +18794,7 @@
                 <a:ea typeface="맑은 고딕" pitchFamily="34" charset="-122"/>
                 <a:cs typeface="맑은 고딕" pitchFamily="34" charset="-120"/>
               </a:rPr>
-              <a:t> 측정 — ISO 8217 한계 520 µm, EN 590 한계 460 µm를 </a:t>
+              <a:t> — ISO 8217 520, EN 590 460 을 </a:t>
             </a:r>
             <a:pPr indent="0" marL="0">
               <a:lnSpc>
@@ -18833,7 +18842,76 @@
         </p:nvSpPr>
         <p:spPr>
           <a:xfrm>
-            <a:off x="566928" y="5010912"/>
+            <a:off x="5431536" y="4553712"/>
+            <a:ext cx="5934456" cy="347472"/>
+          </a:xfrm>
+          <a:prstGeom prst="roundRect">
+            <a:avLst>
+              <a:gd name="adj" fmla="val 15789"/>
+            </a:avLst>
+          </a:prstGeom>
+          <a:solidFill>
+            <a:srgbClr val="EEF2F9"/>
+          </a:solidFill>
+          <a:ln w="12700">
+            <a:solidFill>
+              <a:srgbClr val="333333"/>
+            </a:solidFill>
+            <a:prstDash val="solid"/>
+          </a:ln>
+        </p:spPr>
+      </p:sp>
+      <p:sp>
+        <p:nvSpPr>
+          <p:cNvPr id="45" name="Text 43"/>
+          <p:cNvSpPr/>
+          <p:nvPr/>
+        </p:nvSpPr>
+        <p:spPr>
+          <a:xfrm>
+            <a:off x="5541264" y="4553712"/>
+            <a:ext cx="5715000" cy="347472"/>
+          </a:xfrm>
+          <a:prstGeom prst="rect">
+            <a:avLst/>
+          </a:prstGeom>
+          <a:noFill/>
+          <a:ln/>
+        </p:spPr>
+        <p:txBody>
+          <a:bodyPr wrap="square" lIns="0" tIns="0" rIns="0" bIns="0" rtlCol="0" anchor="ctr"/>
+          <a:lstStyle/>
+          <a:p>
+            <a:pPr indent="0" marL="0">
+              <a:lnSpc>
+                <a:spcPts val="1300"/>
+              </a:lnSpc>
+              <a:buNone/>
+            </a:pPr>
+            <a:r>
+              <a:rPr lang="en-US" sz="950" i="1" dirty="0">
+                <a:solidFill>
+                  <a:srgbClr val="2E5C8A"/>
+                </a:solidFill>
+                <a:latin typeface="맑은 고딕" pitchFamily="34" charset="0"/>
+                <a:ea typeface="맑은 고딕" pitchFamily="34" charset="-122"/>
+                <a:cs typeface="맑은 고딕" pitchFamily="34" charset="-120"/>
+              </a:rPr>
+              <a:t>마모흔은 시험구(⌀6 mm 볼)에 생긴 자국의 지름이며 펌프 내부 치수가 아닙니다. 한계선은 실제 분사장비 고장 이력에서 정해졌습니다.</a:t>
+            </a:r>
+            <a:endParaRPr lang="en-US" sz="950" dirty="0"/>
+          </a:p>
+        </p:txBody>
+      </p:sp>
+      <p:sp>
+        <p:nvSpPr>
+          <p:cNvPr id="46" name="Shape 44"/>
+          <p:cNvSpPr/>
+          <p:nvPr/>
+        </p:nvSpPr>
+        <p:spPr>
+          <a:xfrm>
+            <a:off x="566928" y="5102352"/>
             <a:ext cx="11057839" cy="786384"/>
           </a:xfrm>
           <a:prstGeom prst="roundRect">
@@ -18854,13 +18932,13 @@
       </p:sp>
       <p:sp>
         <p:nvSpPr>
-          <p:cNvPr id="45" name="Text 43"/>
-          <p:cNvSpPr/>
-          <p:nvPr/>
-        </p:nvSpPr>
-        <p:spPr>
-          <a:xfrm>
-            <a:off x="795528" y="5010912"/>
+          <p:cNvPr id="47" name="Text 45"/>
+          <p:cNvSpPr/>
+          <p:nvPr/>
+        </p:nvSpPr>
+        <p:spPr>
+          <a:xfrm>
+            <a:off x="795528" y="5102352"/>
             <a:ext cx="10600639" cy="786384"/>
           </a:xfrm>
           <a:prstGeom prst="rect">
@@ -18921,13 +18999,13 @@
       </p:sp>
       <p:sp>
         <p:nvSpPr>
-          <p:cNvPr id="46" name="Text 44"/>
-          <p:cNvSpPr/>
-          <p:nvPr/>
-        </p:nvSpPr>
-        <p:spPr>
-          <a:xfrm>
-            <a:off x="566928" y="5925312"/>
+          <p:cNvPr id="48" name="Text 46"/>
+          <p:cNvSpPr/>
+          <p:nvPr/>
+        </p:nvSpPr>
+        <p:spPr>
+          <a:xfrm>
+            <a:off x="566928" y="5980176"/>
             <a:ext cx="11057839" cy="219456"/>
           </a:xfrm>
           <a:prstGeom prst="rect">
@@ -20528,7 +20606,7 @@
                 <a:ea typeface="맑은 고딕" pitchFamily="34" charset="-122"/>
                 <a:cs typeface="맑은 고딕" pitchFamily="34" charset="-120"/>
               </a:rPr>
-              <a:t>150 ppm 투입으로 535 → 355 µm. 마모흔 34% 감소, 두 규격을 모두 여유 있게 통과합니다.</a:t>
+              <a:t>100 ppm만으로도 두 규격을 모두 통과합니다. 중요한 것은 감소폭이 아니라 합격선을 넘었다는 사실입니다.</a:t>
             </a:r>
             <a:pPr algn="ctr" indent="0" marL="0">
               <a:buNone/>

</xml_diff>

<commit_message>
Add a slide that turns the lubricity case into the reader's own check
The lubricity section stopped at "the fuel is bad, the additive helps",
which is vendor logic. This adds the step that converts an engineer:
open your own analysis report, look up your own OEM limit, place the
number in a judgement band, and price your own spares against the dose.

Leads with the symptom an engineer already recognises — spare
replacement intervals shortening — and leaves the cost boxes blank so
the audience fills them with their own figures.

Speaker notes carry two honesty guards: changeover pump stiffness is
thermal rather than lubricity, and the 460 um figure comes from
automotive injection equipment, so the ask is to check the vessel's own
OEM limit rather than to trust ours.

Co-Authored-By: Claude Opus 5 <noreply@anthropic.com>
Claude-Session: https://claude.ai/code/session_0181AXsH7YB1d1u5cHBfg2wM
</commit_message>
<xml_diff>
--- a/deck/fuel_training_deck.pptx
+++ b/deck/fuel_training_deck.pptx
@@ -21,9 +21,10 @@
     <p:sldId id="269" r:id="rId15"/>
     <p:sldId id="270" r:id="rId16"/>
     <p:sldId id="271" r:id="rId17"/>
+    <p:sldId id="272" r:id="rId18"/>
   </p:sldIdLst>
   <p:notesMasterIdLst>
-    <p:notesMasterId r:id="rId18"/>
+    <p:notesMasterId r:id="rId19"/>
   </p:notesMasterIdLst>
   <p:sldSz cx="12192000" cy="6858000"/>
   <p:notesSz cx="6858000" cy="12192000"/>
@@ -1813,6 +1814,98 @@
             <a:fld id="{F7021451-1387-4CA6-816F-3879F97B5CBC}" type="slidenum">
               <a:rPr lang="en-US"/>
               <a:t>16</a:t>
+            </a:fld>
+            <a:endParaRPr lang="en-US"/>
+          </a:p>
+        </p:txBody>
+      </p:sp>
+    </p:spTree>
+    <p:extLst>
+      <p:ext uri="{BB962C8B-B14F-4D97-AF65-F5344CB8AC3E}">
+        <p14:creationId xmlns:p14="http://schemas.microsoft.com/office/powerpoint/2010/main" val="1024086991"/>
+      </p:ext>
+    </p:extLst>
+  </p:cSld>
+  <p:clrMapOvr>
+    <a:masterClrMapping/>
+  </p:clrMapOvr>
+</p:notes>
+</file>
+
+<file path=ppt/notesSlides/notesSlide17.xml><?xml version="1.0" encoding="utf-8"?>
+<p:notes xmlns:a="http://schemas.openxmlformats.org/drawingml/2006/main" xmlns:r="http://schemas.openxmlformats.org/officeDocument/2006/relationships" xmlns:p="http://schemas.openxmlformats.org/presentationml/2006/main">
+  <p:cSld>
+    <p:spTree>
+      <p:nvGrpSpPr>
+        <p:cNvPr id="1" name=""/>
+        <p:cNvGrpSpPr/>
+        <p:nvPr/>
+      </p:nvGrpSpPr>
+      <p:grpSpPr>
+        <a:xfrm>
+          <a:off x="0" y="0"/>
+          <a:ext cx="0" cy="0"/>
+          <a:chOff x="0" y="0"/>
+          <a:chExt cx="0" cy="0"/>
+        </a:xfrm>
+      </p:grpSpPr>
+      <p:sp>
+        <p:nvSpPr>
+          <p:cNvPr id="2" name="Slide Image Placeholder 1"/>
+          <p:cNvSpPr>
+            <a:spLocks noGrp="1" noRot="1" noChangeAspect="1"/>
+          </p:cNvSpPr>
+          <p:nvPr>
+            <p:ph type="sldImg"/>
+          </p:nvPr>
+        </p:nvSpPr>
+        <p:spPr/>
+      </p:sp>
+      <p:sp>
+        <p:nvSpPr>
+          <p:cNvPr id="3" name="Notes Placeholder 2"/>
+          <p:cNvSpPr>
+            <a:spLocks noGrp="1"/>
+          </p:cNvSpPr>
+          <p:nvPr>
+            <p:ph type="body" idx="1"/>
+          </p:nvPr>
+        </p:nvSpPr>
+        <p:spPr/>
+        <p:txBody>
+          <a:bodyPr/>
+          <a:lstStyle/>
+          <a:p>
+            <a:r>
+              <a:rPr lang="en-US" dirty="0"/>
+              <a:t>이 장이 실무자를 움직이는 장입니다. 제품을 팔러 온 것이 아니라, 각자 배의 자료를 열어보게 만드는 것이 목적입니다.
+먼저 상단 질문으로 시작하십시오. 스페어 교체 주기가 짧아졌다는 감각은 기관장이라면 대부분 갖고 있습니다. 다만 정직하게 짚어야 할 것이 있습니다 — 연료 전환 시 펌프가 뻑뻑해지는 현상은 대개 열충격과 점도 급변 때문이지 윤활성 때문이 아닙니다. 이 둘을 섞어 말하면 아는 사람에게 바로 걸립니다. 윤활성의 신호는 급성 증상이 아니라 마모가 누적되어 교체 주기가 서서히 짧아지는 것입니다.
+핵심 메시지는 하나입니다. 촉매 미분, 수분, 슬러지는 배에서 눈으로 확인됩니다 — 필터 차압, 퓨리파이어 슬러지량, 육안 검사로 잡힙니다. 그런데 윤활성만은 본선에 아무 지표가 없습니다. 성적서가 돌아올 때는 이미 그 연료를 태운 뒤입니다. 그래서 사후 대응이 불가능하고 예방만 가능합니다.
+STEP 02에서 EN 590의 460은 자동차용 분사장비 기준에서 나온 값이라는 점을 밝히십시오. 선박 주기관에 그대로 들이대면 과장입니다. 그래서 우리 숫자를 믿으라고 하지 말고, 본선 엔진 매뉴얼의 허용치를 직접 확인하시라고 하십시오. 본인이 찾은 숫자가 우리가 제시한 숫자보다 훨씬 강하게 작용합니다.
+STEP 04는 일부러 비워 두었습니다. 스페어 단가는 선사마다 다르므로 각자 채우게 하십시오. 스스로 계산한 금액이 설득의 마지막 조각입니다.</a:t>
+            </a:r>
+            <a:endParaRPr lang="en-US" dirty="0"/>
+          </a:p>
+        </p:txBody>
+      </p:sp>
+      <p:sp>
+        <p:nvSpPr>
+          <p:cNvPr id="4" name="Slide Number Placeholder 3"/>
+          <p:cNvSpPr>
+            <a:spLocks noGrp="1"/>
+          </p:cNvSpPr>
+          <p:nvPr>
+            <p:ph type="sldNum" sz="quarter" idx="10"/>
+          </p:nvPr>
+        </p:nvSpPr>
+        <p:spPr/>
+        <p:txBody>
+          <a:bodyPr/>
+          <a:lstStyle/>
+          <a:p>
+            <a:fld id="{F7021451-1387-4CA6-816F-3879F97B5CBC}" type="slidenum">
+              <a:rPr lang="en-US"/>
+              <a:t>17</a:t>
             </a:fld>
             <a:endParaRPr lang="en-US"/>
           </a:p>
@@ -20673,6 +20766,1800 @@
 </p:sld>
 </file>
 
+<file path=ppt/slides/slide17.xml><?xml version="1.0" encoding="utf-8"?>
+<p:sld xmlns:a="http://schemas.openxmlformats.org/drawingml/2006/main" xmlns:r="http://schemas.openxmlformats.org/officeDocument/2006/relationships" xmlns:p="http://schemas.openxmlformats.org/presentationml/2006/main">
+  <p:cSld name="Slide 17">
+    <p:bg>
+      <p:bgPr>
+        <a:solidFill>
+          <a:srgbClr val="F4F6FB"/>
+        </a:solidFill>
+      </p:bgPr>
+    </p:bg>
+    <p:spTree>
+      <p:nvGrpSpPr>
+        <p:cNvPr id="1" name=""/>
+        <p:cNvGrpSpPr/>
+        <p:nvPr/>
+      </p:nvGrpSpPr>
+      <p:grpSpPr>
+        <a:xfrm>
+          <a:off x="0" y="0"/>
+          <a:ext cx="0" cy="0"/>
+          <a:chOff x="0" y="0"/>
+          <a:chExt cx="0" cy="0"/>
+        </a:xfrm>
+      </p:grpSpPr>
+      <p:sp>
+        <p:nvSpPr>
+          <p:cNvPr id="2" name="Text 0"/>
+          <p:cNvSpPr/>
+          <p:nvPr/>
+        </p:nvSpPr>
+        <p:spPr>
+          <a:xfrm>
+            <a:off x="566928" y="402336"/>
+            <a:ext cx="7315200" cy="256032"/>
+          </a:xfrm>
+          <a:prstGeom prst="rect">
+            <a:avLst/>
+          </a:prstGeom>
+          <a:noFill/>
+          <a:ln/>
+        </p:spPr>
+        <p:txBody>
+          <a:bodyPr wrap="square" lIns="0" tIns="0" rIns="0" bIns="0" rtlCol="0" anchor="ctr"/>
+          <a:lstStyle/>
+          <a:p>
+            <a:pPr algn="l" indent="0" marL="0">
+              <a:buNone/>
+            </a:pPr>
+            <a:r>
+              <a:rPr lang="en-US" sz="1150" b="1" spc="240" kern="0" dirty="0">
+                <a:solidFill>
+                  <a:srgbClr val="E17B34"/>
+                </a:solidFill>
+                <a:latin typeface="맑은 고딕" pitchFamily="34" charset="0"/>
+                <a:ea typeface="맑은 고딕" pitchFamily="34" charset="-122"/>
+                <a:cs typeface="맑은 고딕" pitchFamily="34" charset="-120"/>
+              </a:rPr>
+              <a:t>16   윤활성 ③</a:t>
+            </a:r>
+            <a:endParaRPr lang="en-US" sz="1150" dirty="0"/>
+          </a:p>
+        </p:txBody>
+      </p:sp>
+      <p:sp>
+        <p:nvSpPr>
+          <p:cNvPr id="3" name="Text 1"/>
+          <p:cNvSpPr/>
+          <p:nvPr/>
+        </p:nvSpPr>
+        <p:spPr>
+          <a:xfrm>
+            <a:off x="566928" y="694944"/>
+            <a:ext cx="11057839" cy="713232"/>
+          </a:xfrm>
+          <a:prstGeom prst="rect">
+            <a:avLst/>
+          </a:prstGeom>
+          <a:noFill/>
+          <a:ln/>
+        </p:spPr>
+        <p:txBody>
+          <a:bodyPr wrap="square" lIns="0" tIns="0" rIns="0" bIns="0" rtlCol="0" anchor="ctr"/>
+          <a:lstStyle/>
+          <a:p>
+            <a:pPr algn="l" indent="0" marL="0">
+              <a:buNone/>
+            </a:pPr>
+            <a:r>
+              <a:rPr lang="en-US" sz="3600" dirty="0">
+                <a:solidFill>
+                  <a:srgbClr val="1B3A5C"/>
+                </a:solidFill>
+                <a:latin typeface="바탕" pitchFamily="34" charset="0"/>
+                <a:ea typeface="바탕" pitchFamily="34" charset="-122"/>
+                <a:cs typeface="바탕" pitchFamily="34" charset="-120"/>
+              </a:rPr>
+              <a:t>우리 배도 해당되는지, 직접 확인하는 법</a:t>
+            </a:r>
+            <a:endParaRPr lang="en-US" sz="3600" dirty="0"/>
+          </a:p>
+        </p:txBody>
+      </p:sp>
+      <p:sp>
+        <p:nvSpPr>
+          <p:cNvPr id="4" name="Text 2"/>
+          <p:cNvSpPr/>
+          <p:nvPr/>
+        </p:nvSpPr>
+        <p:spPr>
+          <a:xfrm>
+            <a:off x="566928" y="6419088"/>
+            <a:ext cx="8778240" cy="274320"/>
+          </a:xfrm>
+          <a:prstGeom prst="rect">
+            <a:avLst/>
+          </a:prstGeom>
+          <a:noFill/>
+          <a:ln/>
+        </p:spPr>
+        <p:txBody>
+          <a:bodyPr wrap="square" lIns="0" tIns="0" rIns="0" bIns="0" rtlCol="0" anchor="ctr"/>
+          <a:lstStyle/>
+          <a:p>
+            <a:pPr indent="0" marL="0">
+              <a:buNone/>
+            </a:pPr>
+            <a:r>
+              <a:rPr lang="en-US" sz="850" dirty="0">
+                <a:solidFill>
+                  <a:srgbClr val="8A94A6"/>
+                </a:solidFill>
+                <a:latin typeface="맑은 고딕" pitchFamily="34" charset="0"/>
+                <a:ea typeface="맑은 고딕" pitchFamily="34" charset="-122"/>
+                <a:cs typeface="맑은 고딕" pitchFamily="34" charset="-120"/>
+              </a:rPr>
+              <a:t>Classified as Internal - This content is proprietary information intended for employees and partners only.</a:t>
+            </a:r>
+            <a:endParaRPr lang="en-US" sz="850" dirty="0"/>
+          </a:p>
+        </p:txBody>
+      </p:sp>
+      <p:sp>
+        <p:nvSpPr>
+          <p:cNvPr id="5" name="Text 3"/>
+          <p:cNvSpPr/>
+          <p:nvPr/>
+        </p:nvSpPr>
+        <p:spPr>
+          <a:xfrm>
+            <a:off x="11155680" y="6419088"/>
+            <a:ext cx="502920" cy="274320"/>
+          </a:xfrm>
+          <a:prstGeom prst="rect">
+            <a:avLst/>
+          </a:prstGeom>
+          <a:noFill/>
+          <a:ln/>
+        </p:spPr>
+        <p:txBody>
+          <a:bodyPr wrap="square" lIns="0" tIns="0" rIns="0" bIns="0" rtlCol="0" anchor="ctr"/>
+          <a:lstStyle/>
+          <a:p>
+            <a:pPr algn="r" indent="0" marL="0">
+              <a:buNone/>
+            </a:pPr>
+            <a:r>
+              <a:rPr lang="en-US" sz="950" dirty="0">
+                <a:solidFill>
+                  <a:srgbClr val="8A94A6"/>
+                </a:solidFill>
+                <a:latin typeface="맑은 고딕" pitchFamily="34" charset="0"/>
+                <a:ea typeface="맑은 고딕" pitchFamily="34" charset="-122"/>
+                <a:cs typeface="맑은 고딕" pitchFamily="34" charset="-120"/>
+              </a:rPr>
+              <a:t>17</a:t>
+            </a:r>
+            <a:endParaRPr lang="en-US" sz="950" dirty="0"/>
+          </a:p>
+        </p:txBody>
+      </p:sp>
+      <p:sp>
+        <p:nvSpPr>
+          <p:cNvPr id="6" name="Shape 4"/>
+          <p:cNvSpPr/>
+          <p:nvPr/>
+        </p:nvSpPr>
+        <p:spPr>
+          <a:xfrm>
+            <a:off x="566928" y="1554480"/>
+            <a:ext cx="11057839" cy="420624"/>
+          </a:xfrm>
+          <a:prstGeom prst="roundRect">
+            <a:avLst>
+              <a:gd name="adj" fmla="val 15217"/>
+            </a:avLst>
+          </a:prstGeom>
+          <a:solidFill>
+            <a:srgbClr val="FDF2E9"/>
+          </a:solidFill>
+          <a:ln w="12700">
+            <a:solidFill>
+              <a:srgbClr val="333333"/>
+            </a:solidFill>
+            <a:prstDash val="solid"/>
+          </a:ln>
+        </p:spPr>
+      </p:sp>
+      <p:sp>
+        <p:nvSpPr>
+          <p:cNvPr id="7" name="Text 5"/>
+          <p:cNvSpPr/>
+          <p:nvPr/>
+        </p:nvSpPr>
+        <p:spPr>
+          <a:xfrm>
+            <a:off x="841248" y="1554480"/>
+            <a:ext cx="10509199" cy="420624"/>
+          </a:xfrm>
+          <a:prstGeom prst="rect">
+            <a:avLst/>
+          </a:prstGeom>
+          <a:noFill/>
+          <a:ln/>
+        </p:spPr>
+        <p:txBody>
+          <a:bodyPr wrap="square" lIns="0" tIns="0" rIns="0" bIns="0" rtlCol="0" anchor="ctr"/>
+          <a:lstStyle/>
+          <a:p>
+            <a:pPr indent="0" marL="0">
+              <a:buNone/>
+            </a:pPr>
+            <a:r>
+              <a:rPr lang="en-US" sz="1100" b="1" dirty="0">
+                <a:solidFill>
+                  <a:srgbClr val="E17B34"/>
+                </a:solidFill>
+                <a:latin typeface="맑은 고딕" pitchFamily="34" charset="0"/>
+                <a:ea typeface="맑은 고딕" pitchFamily="34" charset="-122"/>
+                <a:cs typeface="맑은 고딕" pitchFamily="34" charset="-120"/>
+              </a:rPr>
+              <a:t>먼저 이것부터 —  </a:t>
+            </a:r>
+            <a:pPr indent="0" marL="0">
+              <a:buNone/>
+            </a:pPr>
+            <a:r>
+              <a:rPr lang="en-US" sz="1100" dirty="0">
+                <a:solidFill>
+                  <a:srgbClr val="3D4A5C"/>
+                </a:solidFill>
+                <a:latin typeface="맑은 고딕" pitchFamily="34" charset="0"/>
+                <a:ea typeface="맑은 고딕" pitchFamily="34" charset="-122"/>
+                <a:cs typeface="맑은 고딕" pitchFamily="34" charset="-120"/>
+              </a:rPr>
+              <a:t>지난 2년간 연료펌프 플런저·인젝터 스페어 교체 주기가 짧아졌습니까?  그렇다면 윤활성은 의심할 이유가 있는 후보입니다.</a:t>
+            </a:r>
+            <a:endParaRPr lang="en-US" sz="1100" dirty="0"/>
+          </a:p>
+        </p:txBody>
+      </p:sp>
+      <p:sp>
+        <p:nvSpPr>
+          <p:cNvPr id="8" name="Shape 6"/>
+          <p:cNvSpPr/>
+          <p:nvPr/>
+        </p:nvSpPr>
+        <p:spPr>
+          <a:xfrm>
+            <a:off x="566928" y="2139696"/>
+            <a:ext cx="2531288" cy="2670048"/>
+          </a:xfrm>
+          <a:prstGeom prst="roundRect">
+            <a:avLst>
+              <a:gd name="adj" fmla="val 5057"/>
+            </a:avLst>
+          </a:prstGeom>
+          <a:solidFill>
+            <a:srgbClr val="FFFFFF"/>
+          </a:solidFill>
+          <a:ln w="9525">
+            <a:solidFill>
+              <a:srgbClr val="EDF1F8"/>
+            </a:solidFill>
+            <a:prstDash val="solid"/>
+          </a:ln>
+          <a:effectLst>
+            <a:outerShdw sx="100000" sy="100000" kx="0" ky="0" algn="bl" rotWithShape="0" blurRad="127000" dist="25400" dir="5400000">
+              <a:srgbClr val="9BAAC4">
+                <a:alpha val="22000"/>
+              </a:srgbClr>
+            </a:outerShdw>
+          </a:effectLst>
+        </p:spPr>
+      </p:sp>
+      <p:sp>
+        <p:nvSpPr>
+          <p:cNvPr id="9" name="Text 7"/>
+          <p:cNvSpPr/>
+          <p:nvPr/>
+        </p:nvSpPr>
+        <p:spPr>
+          <a:xfrm>
+            <a:off x="786384" y="2322576"/>
+            <a:ext cx="2092376" cy="219456"/>
+          </a:xfrm>
+          <a:prstGeom prst="rect">
+            <a:avLst/>
+          </a:prstGeom>
+          <a:noFill/>
+          <a:ln/>
+        </p:spPr>
+        <p:txBody>
+          <a:bodyPr wrap="square" lIns="0" tIns="0" rIns="0" bIns="0" rtlCol="0" anchor="ctr"/>
+          <a:lstStyle/>
+          <a:p>
+            <a:pPr indent="0" marL="0">
+              <a:buNone/>
+            </a:pPr>
+            <a:r>
+              <a:rPr lang="en-US" sz="950" b="1" spc="180" kern="0" dirty="0">
+                <a:solidFill>
+                  <a:srgbClr val="2E5C8A"/>
+                </a:solidFill>
+                <a:latin typeface="맑은 고딕" pitchFamily="34" charset="0"/>
+                <a:ea typeface="맑은 고딕" pitchFamily="34" charset="-122"/>
+                <a:cs typeface="맑은 고딕" pitchFamily="34" charset="-120"/>
+              </a:rPr>
+              <a:t>STEP 01</a:t>
+            </a:r>
+            <a:endParaRPr lang="en-US" sz="950" dirty="0"/>
+          </a:p>
+        </p:txBody>
+      </p:sp>
+      <p:sp>
+        <p:nvSpPr>
+          <p:cNvPr id="10" name="Text 8"/>
+          <p:cNvSpPr/>
+          <p:nvPr/>
+        </p:nvSpPr>
+        <p:spPr>
+          <a:xfrm>
+            <a:off x="786384" y="2542032"/>
+            <a:ext cx="2092376" cy="310896"/>
+          </a:xfrm>
+          <a:prstGeom prst="rect">
+            <a:avLst/>
+          </a:prstGeom>
+          <a:noFill/>
+          <a:ln/>
+        </p:spPr>
+        <p:txBody>
+          <a:bodyPr wrap="square" lIns="0" tIns="0" rIns="0" bIns="0" rtlCol="0" anchor="ctr"/>
+          <a:lstStyle/>
+          <a:p>
+            <a:pPr indent="0" marL="0">
+              <a:buNone/>
+            </a:pPr>
+            <a:r>
+              <a:rPr lang="en-US" sz="1300" b="1" dirty="0">
+                <a:solidFill>
+                  <a:srgbClr val="1B3A5C"/>
+                </a:solidFill>
+                <a:latin typeface="맑은 고딕" pitchFamily="34" charset="0"/>
+                <a:ea typeface="맑은 고딕" pitchFamily="34" charset="-122"/>
+                <a:cs typeface="맑은 고딕" pitchFamily="34" charset="-120"/>
+              </a:rPr>
+              <a:t>성적서를 여십시오</a:t>
+            </a:r>
+            <a:endParaRPr lang="en-US" sz="1300" dirty="0"/>
+          </a:p>
+        </p:txBody>
+      </p:sp>
+      <p:sp>
+        <p:nvSpPr>
+          <p:cNvPr id="11" name="Text 9"/>
+          <p:cNvSpPr/>
+          <p:nvPr/>
+        </p:nvSpPr>
+        <p:spPr>
+          <a:xfrm>
+            <a:off x="786384" y="2926080"/>
+            <a:ext cx="2092376" cy="1737360"/>
+          </a:xfrm>
+          <a:prstGeom prst="rect">
+            <a:avLst/>
+          </a:prstGeom>
+          <a:noFill/>
+          <a:ln/>
+        </p:spPr>
+        <p:txBody>
+          <a:bodyPr wrap="square" lIns="0" tIns="0" rIns="0" bIns="0" rtlCol="0" anchor="t"/>
+          <a:lstStyle/>
+          <a:p>
+            <a:pPr indent="0" marL="0">
+              <a:lnSpc>
+                <a:spcPts val="1500"/>
+              </a:lnSpc>
+              <a:buNone/>
+            </a:pPr>
+            <a:r>
+              <a:rPr lang="en-US" sz="1000" dirty="0">
+                <a:solidFill>
+                  <a:srgbClr val="3D4A5C"/>
+                </a:solidFill>
+                <a:latin typeface="맑은 고딕" pitchFamily="34" charset="0"/>
+                <a:ea typeface="맑은 고딕" pitchFamily="34" charset="-122"/>
+                <a:cs typeface="맑은 고딕" pitchFamily="34" charset="-120"/>
+              </a:rPr>
+              <a:t>최근 MGO 분석 성적서에</a:t>
+            </a:r>
+            <a:endParaRPr lang="en-US" sz="1000" dirty="0"/>
+          </a:p>
+          <a:p>
+            <a:pPr indent="0" marL="0">
+              <a:lnSpc>
+                <a:spcPts val="1500"/>
+              </a:lnSpc>
+              <a:buNone/>
+            </a:pPr>
+            <a:r>
+              <a:rPr lang="en-US" sz="1000" dirty="0">
+                <a:solidFill>
+                  <a:srgbClr val="3D4A5C"/>
+                </a:solidFill>
+                <a:latin typeface="맑은 고딕" pitchFamily="34" charset="0"/>
+                <a:ea typeface="맑은 고딕" pitchFamily="34" charset="-122"/>
+                <a:cs typeface="맑은 고딕" pitchFamily="34" charset="-120"/>
+              </a:rPr>
+              <a:t>Lubricity (HFRR) 항목이</a:t>
+            </a:r>
+            <a:endParaRPr lang="en-US" sz="1000" dirty="0"/>
+          </a:p>
+          <a:p>
+            <a:pPr indent="0" marL="0">
+              <a:lnSpc>
+                <a:spcPts val="1500"/>
+              </a:lnSpc>
+              <a:buNone/>
+            </a:pPr>
+            <a:r>
+              <a:rPr lang="en-US" sz="1000" dirty="0">
+                <a:solidFill>
+                  <a:srgbClr val="3D4A5C"/>
+                </a:solidFill>
+                <a:latin typeface="맑은 고딕" pitchFamily="34" charset="0"/>
+                <a:ea typeface="맑은 고딕" pitchFamily="34" charset="-122"/>
+                <a:cs typeface="맑은 고딕" pitchFamily="34" charset="-120"/>
+              </a:rPr>
+              <a:t>있습니까?</a:t>
+            </a:r>
+            <a:endParaRPr lang="en-US" sz="1000" dirty="0"/>
+          </a:p>
+          <a:p>
+            <a:pPr indent="0" marL="0">
+              <a:lnSpc>
+                <a:spcPts val="1500"/>
+              </a:lnSpc>
+              <a:buNone/>
+            </a:pPr>
+            <a:endParaRPr lang="en-US" sz="1000" dirty="0"/>
+          </a:p>
+          <a:p>
+            <a:pPr indent="0" marL="0">
+              <a:lnSpc>
+                <a:spcPts val="1500"/>
+              </a:lnSpc>
+              <a:buNone/>
+            </a:pPr>
+            <a:r>
+              <a:rPr lang="en-US" sz="1000" dirty="0">
+                <a:solidFill>
+                  <a:srgbClr val="3D4A5C"/>
+                </a:solidFill>
+                <a:latin typeface="맑은 고딕" pitchFamily="34" charset="0"/>
+                <a:ea typeface="맑은 고딕" pitchFamily="34" charset="-122"/>
+                <a:cs typeface="맑은 고딕" pitchFamily="34" charset="-120"/>
+              </a:rPr>
+              <a:t>없다면 시험 자체를 안 한 것입니다.</a:t>
+            </a:r>
+            <a:endParaRPr lang="en-US" sz="1000" dirty="0"/>
+          </a:p>
+          <a:p>
+            <a:pPr indent="0" marL="0">
+              <a:lnSpc>
+                <a:spcPts val="1500"/>
+              </a:lnSpc>
+              <a:buNone/>
+            </a:pPr>
+            <a:r>
+              <a:rPr lang="en-US" sz="1000" dirty="0">
+                <a:solidFill>
+                  <a:srgbClr val="3D4A5C"/>
+                </a:solidFill>
+                <a:latin typeface="맑은 고딕" pitchFamily="34" charset="0"/>
+                <a:ea typeface="맑은 고딕" pitchFamily="34" charset="-122"/>
+                <a:cs typeface="맑은 고딕" pitchFamily="34" charset="-120"/>
+              </a:rPr>
+              <a:t>ISO 8217은 황 0.050% 이하</a:t>
+            </a:r>
+            <a:endParaRPr lang="en-US" sz="1000" dirty="0"/>
+          </a:p>
+          <a:p>
+            <a:pPr indent="0" marL="0">
+              <a:lnSpc>
+                <a:spcPts val="1500"/>
+              </a:lnSpc>
+              <a:buNone/>
+            </a:pPr>
+            <a:r>
+              <a:rPr lang="en-US" sz="1000" dirty="0">
+                <a:solidFill>
+                  <a:srgbClr val="3D4A5C"/>
+                </a:solidFill>
+                <a:latin typeface="맑은 고딕" pitchFamily="34" charset="0"/>
+                <a:ea typeface="맑은 고딕" pitchFamily="34" charset="-122"/>
+                <a:cs typeface="맑은 고딕" pitchFamily="34" charset="-120"/>
+              </a:rPr>
+              <a:t>증류유에 이 시험을 요구합니다.</a:t>
+            </a:r>
+            <a:endParaRPr lang="en-US" sz="1000" dirty="0"/>
+          </a:p>
+        </p:txBody>
+      </p:sp>
+      <p:sp>
+        <p:nvSpPr>
+          <p:cNvPr id="12" name="Shape 10"/>
+          <p:cNvSpPr/>
+          <p:nvPr/>
+        </p:nvSpPr>
+        <p:spPr>
+          <a:xfrm>
+            <a:off x="3409112" y="2139696"/>
+            <a:ext cx="2531288" cy="2670048"/>
+          </a:xfrm>
+          <a:prstGeom prst="roundRect">
+            <a:avLst>
+              <a:gd name="adj" fmla="val 5057"/>
+            </a:avLst>
+          </a:prstGeom>
+          <a:solidFill>
+            <a:srgbClr val="FFFFFF"/>
+          </a:solidFill>
+          <a:ln w="9525">
+            <a:solidFill>
+              <a:srgbClr val="EDF1F8"/>
+            </a:solidFill>
+            <a:prstDash val="solid"/>
+          </a:ln>
+          <a:effectLst>
+            <a:outerShdw sx="100000" sy="100000" kx="0" ky="0" algn="bl" rotWithShape="0" blurRad="127000" dist="25400" dir="5400000">
+              <a:srgbClr val="9BAAC4">
+                <a:alpha val="22000"/>
+              </a:srgbClr>
+            </a:outerShdw>
+          </a:effectLst>
+        </p:spPr>
+      </p:sp>
+      <p:sp>
+        <p:nvSpPr>
+          <p:cNvPr id="13" name="Text 11"/>
+          <p:cNvSpPr/>
+          <p:nvPr/>
+        </p:nvSpPr>
+        <p:spPr>
+          <a:xfrm>
+            <a:off x="3628568" y="2322576"/>
+            <a:ext cx="2092376" cy="219456"/>
+          </a:xfrm>
+          <a:prstGeom prst="rect">
+            <a:avLst/>
+          </a:prstGeom>
+          <a:noFill/>
+          <a:ln/>
+        </p:spPr>
+        <p:txBody>
+          <a:bodyPr wrap="square" lIns="0" tIns="0" rIns="0" bIns="0" rtlCol="0" anchor="ctr"/>
+          <a:lstStyle/>
+          <a:p>
+            <a:pPr indent="0" marL="0">
+              <a:buNone/>
+            </a:pPr>
+            <a:r>
+              <a:rPr lang="en-US" sz="950" b="1" spc="180" kern="0" dirty="0">
+                <a:solidFill>
+                  <a:srgbClr val="2E5C8A"/>
+                </a:solidFill>
+                <a:latin typeface="맑은 고딕" pitchFamily="34" charset="0"/>
+                <a:ea typeface="맑은 고딕" pitchFamily="34" charset="-122"/>
+                <a:cs typeface="맑은 고딕" pitchFamily="34" charset="-120"/>
+              </a:rPr>
+              <a:t>STEP 02</a:t>
+            </a:r>
+            <a:endParaRPr lang="en-US" sz="950" dirty="0"/>
+          </a:p>
+        </p:txBody>
+      </p:sp>
+      <p:sp>
+        <p:nvSpPr>
+          <p:cNvPr id="14" name="Text 12"/>
+          <p:cNvSpPr/>
+          <p:nvPr/>
+        </p:nvSpPr>
+        <p:spPr>
+          <a:xfrm>
+            <a:off x="3628568" y="2542032"/>
+            <a:ext cx="2092376" cy="310896"/>
+          </a:xfrm>
+          <a:prstGeom prst="rect">
+            <a:avLst/>
+          </a:prstGeom>
+          <a:noFill/>
+          <a:ln/>
+        </p:spPr>
+        <p:txBody>
+          <a:bodyPr wrap="square" lIns="0" tIns="0" rIns="0" bIns="0" rtlCol="0" anchor="ctr"/>
+          <a:lstStyle/>
+          <a:p>
+            <a:pPr indent="0" marL="0">
+              <a:buNone/>
+            </a:pPr>
+            <a:r>
+              <a:rPr lang="en-US" sz="1300" b="1" dirty="0">
+                <a:solidFill>
+                  <a:srgbClr val="1B3A5C"/>
+                </a:solidFill>
+                <a:latin typeface="맑은 고딕" pitchFamily="34" charset="0"/>
+                <a:ea typeface="맑은 고딕" pitchFamily="34" charset="-122"/>
+                <a:cs typeface="맑은 고딕" pitchFamily="34" charset="-120"/>
+              </a:rPr>
+              <a:t>OEM 한계를 확인하십시오</a:t>
+            </a:r>
+            <a:endParaRPr lang="en-US" sz="1300" dirty="0"/>
+          </a:p>
+        </p:txBody>
+      </p:sp>
+      <p:sp>
+        <p:nvSpPr>
+          <p:cNvPr id="15" name="Text 13"/>
+          <p:cNvSpPr/>
+          <p:nvPr/>
+        </p:nvSpPr>
+        <p:spPr>
+          <a:xfrm>
+            <a:off x="3628568" y="2926080"/>
+            <a:ext cx="2092376" cy="1737360"/>
+          </a:xfrm>
+          <a:prstGeom prst="rect">
+            <a:avLst/>
+          </a:prstGeom>
+          <a:noFill/>
+          <a:ln/>
+        </p:spPr>
+        <p:txBody>
+          <a:bodyPr wrap="square" lIns="0" tIns="0" rIns="0" bIns="0" rtlCol="0" anchor="t"/>
+          <a:lstStyle/>
+          <a:p>
+            <a:pPr indent="0" marL="0">
+              <a:lnSpc>
+                <a:spcPts val="1500"/>
+              </a:lnSpc>
+              <a:buNone/>
+            </a:pPr>
+            <a:r>
+              <a:rPr lang="en-US" sz="1000" dirty="0">
+                <a:solidFill>
+                  <a:srgbClr val="3D4A5C"/>
+                </a:solidFill>
+                <a:latin typeface="맑은 고딕" pitchFamily="34" charset="0"/>
+                <a:ea typeface="맑은 고딕" pitchFamily="34" charset="-122"/>
+                <a:cs typeface="맑은 고딕" pitchFamily="34" charset="-120"/>
+              </a:rPr>
+              <a:t>본선 엔진 매뉴얼의</a:t>
+            </a:r>
+            <a:endParaRPr lang="en-US" sz="1000" dirty="0"/>
+          </a:p>
+          <a:p>
+            <a:pPr indent="0" marL="0">
+              <a:lnSpc>
+                <a:spcPts val="1500"/>
+              </a:lnSpc>
+              <a:buNone/>
+            </a:pPr>
+            <a:r>
+              <a:rPr lang="en-US" sz="1000" dirty="0">
+                <a:solidFill>
+                  <a:srgbClr val="3D4A5C"/>
+                </a:solidFill>
+                <a:latin typeface="맑은 고딕" pitchFamily="34" charset="0"/>
+                <a:ea typeface="맑은 고딕" pitchFamily="34" charset="-122"/>
+                <a:cs typeface="맑은 고딕" pitchFamily="34" charset="-120"/>
+              </a:rPr>
+              <a:t>윤활성 허용치는 얼마입니까?</a:t>
+            </a:r>
+            <a:endParaRPr lang="en-US" sz="1000" dirty="0"/>
+          </a:p>
+          <a:p>
+            <a:pPr indent="0" marL="0">
+              <a:lnSpc>
+                <a:spcPts val="1500"/>
+              </a:lnSpc>
+              <a:buNone/>
+            </a:pPr>
+            <a:endParaRPr lang="en-US" sz="1000" dirty="0"/>
+          </a:p>
+          <a:p>
+            <a:pPr indent="0" marL="0">
+              <a:lnSpc>
+                <a:spcPts val="1500"/>
+              </a:lnSpc>
+              <a:buNone/>
+            </a:pPr>
+            <a:r>
+              <a:rPr lang="en-US" sz="1000" dirty="0">
+                <a:solidFill>
+                  <a:srgbClr val="3D4A5C"/>
+                </a:solidFill>
+                <a:latin typeface="맑은 고딕" pitchFamily="34" charset="0"/>
+                <a:ea typeface="맑은 고딕" pitchFamily="34" charset="-122"/>
+                <a:cs typeface="맑은 고딕" pitchFamily="34" charset="-120"/>
+              </a:rPr>
+              <a:t>ISO 8217 (선박 증류유)  520 µm</a:t>
+            </a:r>
+            <a:endParaRPr lang="en-US" sz="1000" dirty="0"/>
+          </a:p>
+          <a:p>
+            <a:pPr indent="0" marL="0">
+              <a:lnSpc>
+                <a:spcPts val="1500"/>
+              </a:lnSpc>
+              <a:buNone/>
+            </a:pPr>
+            <a:r>
+              <a:rPr lang="en-US" sz="1000" dirty="0">
+                <a:solidFill>
+                  <a:srgbClr val="3D4A5C"/>
+                </a:solidFill>
+                <a:latin typeface="맑은 고딕" pitchFamily="34" charset="0"/>
+                <a:ea typeface="맑은 고딕" pitchFamily="34" charset="-122"/>
+                <a:cs typeface="맑은 고딕" pitchFamily="34" charset="-120"/>
+              </a:rPr>
+              <a:t>EN 590 (자동차 경유)  460 µm</a:t>
+            </a:r>
+            <a:endParaRPr lang="en-US" sz="1000" dirty="0"/>
+          </a:p>
+          <a:p>
+            <a:pPr indent="0" marL="0">
+              <a:lnSpc>
+                <a:spcPts val="1500"/>
+              </a:lnSpc>
+              <a:buNone/>
+            </a:pPr>
+            <a:endParaRPr lang="en-US" sz="1000" dirty="0"/>
+          </a:p>
+          <a:p>
+            <a:pPr indent="0" marL="0">
+              <a:lnSpc>
+                <a:spcPts val="1500"/>
+              </a:lnSpc>
+              <a:buNone/>
+            </a:pPr>
+            <a:r>
+              <a:rPr lang="en-US" sz="1000" dirty="0">
+                <a:solidFill>
+                  <a:srgbClr val="3D4A5C"/>
+                </a:solidFill>
+                <a:latin typeface="맑은 고딕" pitchFamily="34" charset="0"/>
+                <a:ea typeface="맑은 고딕" pitchFamily="34" charset="-122"/>
+                <a:cs typeface="맑은 고딕" pitchFamily="34" charset="-120"/>
+              </a:rPr>
+              <a:t>OEM이 더 엄격할 수 있습니다.</a:t>
+            </a:r>
+            <a:endParaRPr lang="en-US" sz="1000" dirty="0"/>
+          </a:p>
+        </p:txBody>
+      </p:sp>
+      <p:sp>
+        <p:nvSpPr>
+          <p:cNvPr id="16" name="Shape 14"/>
+          <p:cNvSpPr/>
+          <p:nvPr/>
+        </p:nvSpPr>
+        <p:spPr>
+          <a:xfrm>
+            <a:off x="6251296" y="2139696"/>
+            <a:ext cx="2531288" cy="2670048"/>
+          </a:xfrm>
+          <a:prstGeom prst="roundRect">
+            <a:avLst>
+              <a:gd name="adj" fmla="val 5057"/>
+            </a:avLst>
+          </a:prstGeom>
+          <a:solidFill>
+            <a:srgbClr val="FFFFFF"/>
+          </a:solidFill>
+          <a:ln w="9525">
+            <a:solidFill>
+              <a:srgbClr val="EDF1F8"/>
+            </a:solidFill>
+            <a:prstDash val="solid"/>
+          </a:ln>
+          <a:effectLst>
+            <a:outerShdw sx="100000" sy="100000" kx="0" ky="0" algn="bl" rotWithShape="0" blurRad="127000" dist="25400" dir="5400000">
+              <a:srgbClr val="9BAAC4">
+                <a:alpha val="22000"/>
+              </a:srgbClr>
+            </a:outerShdw>
+          </a:effectLst>
+        </p:spPr>
+      </p:sp>
+      <p:sp>
+        <p:nvSpPr>
+          <p:cNvPr id="17" name="Text 15"/>
+          <p:cNvSpPr/>
+          <p:nvPr/>
+        </p:nvSpPr>
+        <p:spPr>
+          <a:xfrm>
+            <a:off x="6470752" y="2322576"/>
+            <a:ext cx="2092376" cy="219456"/>
+          </a:xfrm>
+          <a:prstGeom prst="rect">
+            <a:avLst/>
+          </a:prstGeom>
+          <a:noFill/>
+          <a:ln/>
+        </p:spPr>
+        <p:txBody>
+          <a:bodyPr wrap="square" lIns="0" tIns="0" rIns="0" bIns="0" rtlCol="0" anchor="ctr"/>
+          <a:lstStyle/>
+          <a:p>
+            <a:pPr indent="0" marL="0">
+              <a:buNone/>
+            </a:pPr>
+            <a:r>
+              <a:rPr lang="en-US" sz="950" b="1" spc="180" kern="0" dirty="0">
+                <a:solidFill>
+                  <a:srgbClr val="E17B34"/>
+                </a:solidFill>
+                <a:latin typeface="맑은 고딕" pitchFamily="34" charset="0"/>
+                <a:ea typeface="맑은 고딕" pitchFamily="34" charset="-122"/>
+                <a:cs typeface="맑은 고딕" pitchFamily="34" charset="-120"/>
+              </a:rPr>
+              <a:t>STEP 03</a:t>
+            </a:r>
+            <a:endParaRPr lang="en-US" sz="950" dirty="0"/>
+          </a:p>
+        </p:txBody>
+      </p:sp>
+      <p:sp>
+        <p:nvSpPr>
+          <p:cNvPr id="18" name="Text 16"/>
+          <p:cNvSpPr/>
+          <p:nvPr/>
+        </p:nvSpPr>
+        <p:spPr>
+          <a:xfrm>
+            <a:off x="6470752" y="2542032"/>
+            <a:ext cx="2092376" cy="310896"/>
+          </a:xfrm>
+          <a:prstGeom prst="rect">
+            <a:avLst/>
+          </a:prstGeom>
+          <a:noFill/>
+          <a:ln/>
+        </p:spPr>
+        <p:txBody>
+          <a:bodyPr wrap="square" lIns="0" tIns="0" rIns="0" bIns="0" rtlCol="0" anchor="ctr"/>
+          <a:lstStyle/>
+          <a:p>
+            <a:pPr indent="0" marL="0">
+              <a:buNone/>
+            </a:pPr>
+            <a:r>
+              <a:rPr lang="en-US" sz="1300" b="1" dirty="0">
+                <a:solidFill>
+                  <a:srgbClr val="1B3A5C"/>
+                </a:solidFill>
+                <a:latin typeface="맑은 고딕" pitchFamily="34" charset="0"/>
+                <a:ea typeface="맑은 고딕" pitchFamily="34" charset="-122"/>
+                <a:cs typeface="맑은 고딕" pitchFamily="34" charset="-120"/>
+              </a:rPr>
+              <a:t>두 숫자를 비교하십시오</a:t>
+            </a:r>
+            <a:endParaRPr lang="en-US" sz="1300" dirty="0"/>
+          </a:p>
+        </p:txBody>
+      </p:sp>
+      <p:sp>
+        <p:nvSpPr>
+          <p:cNvPr id="19" name="Shape 17"/>
+          <p:cNvSpPr/>
+          <p:nvPr/>
+        </p:nvSpPr>
+        <p:spPr>
+          <a:xfrm>
+            <a:off x="9093479" y="2139696"/>
+            <a:ext cx="2531288" cy="2670048"/>
+          </a:xfrm>
+          <a:prstGeom prst="roundRect">
+            <a:avLst>
+              <a:gd name="adj" fmla="val 5057"/>
+            </a:avLst>
+          </a:prstGeom>
+          <a:solidFill>
+            <a:srgbClr val="FFFFFF"/>
+          </a:solidFill>
+          <a:ln w="9525">
+            <a:solidFill>
+              <a:srgbClr val="EDF1F8"/>
+            </a:solidFill>
+            <a:prstDash val="solid"/>
+          </a:ln>
+          <a:effectLst>
+            <a:outerShdw sx="100000" sy="100000" kx="0" ky="0" algn="bl" rotWithShape="0" blurRad="127000" dist="25400" dir="5400000">
+              <a:srgbClr val="9BAAC4">
+                <a:alpha val="22000"/>
+              </a:srgbClr>
+            </a:outerShdw>
+          </a:effectLst>
+        </p:spPr>
+      </p:sp>
+      <p:sp>
+        <p:nvSpPr>
+          <p:cNvPr id="20" name="Text 18"/>
+          <p:cNvSpPr/>
+          <p:nvPr/>
+        </p:nvSpPr>
+        <p:spPr>
+          <a:xfrm>
+            <a:off x="9312935" y="2322576"/>
+            <a:ext cx="2092376" cy="219456"/>
+          </a:xfrm>
+          <a:prstGeom prst="rect">
+            <a:avLst/>
+          </a:prstGeom>
+          <a:noFill/>
+          <a:ln/>
+        </p:spPr>
+        <p:txBody>
+          <a:bodyPr wrap="square" lIns="0" tIns="0" rIns="0" bIns="0" rtlCol="0" anchor="ctr"/>
+          <a:lstStyle/>
+          <a:p>
+            <a:pPr indent="0" marL="0">
+              <a:buNone/>
+            </a:pPr>
+            <a:r>
+              <a:rPr lang="en-US" sz="950" b="1" spc="180" kern="0" dirty="0">
+                <a:solidFill>
+                  <a:srgbClr val="2E7D5B"/>
+                </a:solidFill>
+                <a:latin typeface="맑은 고딕" pitchFamily="34" charset="0"/>
+                <a:ea typeface="맑은 고딕" pitchFamily="34" charset="-122"/>
+                <a:cs typeface="맑은 고딕" pitchFamily="34" charset="-120"/>
+              </a:rPr>
+              <a:t>STEP 04</a:t>
+            </a:r>
+            <a:endParaRPr lang="en-US" sz="950" dirty="0"/>
+          </a:p>
+        </p:txBody>
+      </p:sp>
+      <p:sp>
+        <p:nvSpPr>
+          <p:cNvPr id="21" name="Text 19"/>
+          <p:cNvSpPr/>
+          <p:nvPr/>
+        </p:nvSpPr>
+        <p:spPr>
+          <a:xfrm>
+            <a:off x="9312935" y="2542032"/>
+            <a:ext cx="2092376" cy="310896"/>
+          </a:xfrm>
+          <a:prstGeom prst="rect">
+            <a:avLst/>
+          </a:prstGeom>
+          <a:noFill/>
+          <a:ln/>
+        </p:spPr>
+        <p:txBody>
+          <a:bodyPr wrap="square" lIns="0" tIns="0" rIns="0" bIns="0" rtlCol="0" anchor="ctr"/>
+          <a:lstStyle/>
+          <a:p>
+            <a:pPr indent="0" marL="0">
+              <a:buNone/>
+            </a:pPr>
+            <a:r>
+              <a:rPr lang="en-US" sz="1300" b="1" dirty="0">
+                <a:solidFill>
+                  <a:srgbClr val="1B3A5C"/>
+                </a:solidFill>
+                <a:latin typeface="맑은 고딕" pitchFamily="34" charset="0"/>
+                <a:ea typeface="맑은 고딕" pitchFamily="34" charset="-122"/>
+                <a:cs typeface="맑은 고딕" pitchFamily="34" charset="-120"/>
+              </a:rPr>
+              <a:t>비용을 비교하십시오</a:t>
+            </a:r>
+            <a:endParaRPr lang="en-US" sz="1300" dirty="0"/>
+          </a:p>
+        </p:txBody>
+      </p:sp>
+      <p:sp>
+        <p:nvSpPr>
+          <p:cNvPr id="22" name="Shape 20"/>
+          <p:cNvSpPr/>
+          <p:nvPr/>
+        </p:nvSpPr>
+        <p:spPr>
+          <a:xfrm>
+            <a:off x="6470752" y="2962656"/>
+            <a:ext cx="2092376" cy="493776"/>
+          </a:xfrm>
+          <a:prstGeom prst="roundRect">
+            <a:avLst>
+              <a:gd name="adj" fmla="val 12963"/>
+            </a:avLst>
+          </a:prstGeom>
+          <a:solidFill>
+            <a:srgbClr val="E9F5F0"/>
+          </a:solidFill>
+          <a:ln w="12700">
+            <a:solidFill>
+              <a:srgbClr val="333333"/>
+            </a:solidFill>
+            <a:prstDash val="solid"/>
+          </a:ln>
+        </p:spPr>
+      </p:sp>
+      <p:sp>
+        <p:nvSpPr>
+          <p:cNvPr id="23" name="Text 21"/>
+          <p:cNvSpPr/>
+          <p:nvPr/>
+        </p:nvSpPr>
+        <p:spPr>
+          <a:xfrm>
+            <a:off x="6598768" y="2999232"/>
+            <a:ext cx="1836344" cy="237744"/>
+          </a:xfrm>
+          <a:prstGeom prst="rect">
+            <a:avLst/>
+          </a:prstGeom>
+          <a:noFill/>
+          <a:ln/>
+        </p:spPr>
+        <p:txBody>
+          <a:bodyPr wrap="square" lIns="0" tIns="0" rIns="0" bIns="0" rtlCol="0" anchor="ctr"/>
+          <a:lstStyle/>
+          <a:p>
+            <a:pPr indent="0" marL="0">
+              <a:buNone/>
+            </a:pPr>
+            <a:r>
+              <a:rPr lang="en-US" sz="1100" b="1" dirty="0">
+                <a:solidFill>
+                  <a:srgbClr val="2E7D5B"/>
+                </a:solidFill>
+                <a:latin typeface="맑은 고딕" pitchFamily="34" charset="0"/>
+                <a:ea typeface="맑은 고딕" pitchFamily="34" charset="-122"/>
+                <a:cs typeface="맑은 고딕" pitchFamily="34" charset="-120"/>
+              </a:rPr>
+              <a:t>460 µm 미만</a:t>
+            </a:r>
+            <a:endParaRPr lang="en-US" sz="1100" dirty="0"/>
+          </a:p>
+        </p:txBody>
+      </p:sp>
+      <p:sp>
+        <p:nvSpPr>
+          <p:cNvPr id="24" name="Text 22"/>
+          <p:cNvSpPr/>
+          <p:nvPr/>
+        </p:nvSpPr>
+        <p:spPr>
+          <a:xfrm>
+            <a:off x="6598768" y="3218688"/>
+            <a:ext cx="1836344" cy="201168"/>
+          </a:xfrm>
+          <a:prstGeom prst="rect">
+            <a:avLst/>
+          </a:prstGeom>
+          <a:noFill/>
+          <a:ln/>
+        </p:spPr>
+        <p:txBody>
+          <a:bodyPr wrap="square" lIns="0" tIns="0" rIns="0" bIns="0" rtlCol="0" anchor="ctr"/>
+          <a:lstStyle/>
+          <a:p>
+            <a:pPr indent="0" marL="0">
+              <a:buNone/>
+            </a:pPr>
+            <a:r>
+              <a:rPr lang="en-US" sz="950" dirty="0">
+                <a:solidFill>
+                  <a:srgbClr val="3D4A5C"/>
+                </a:solidFill>
+                <a:latin typeface="맑은 고딕" pitchFamily="34" charset="0"/>
+                <a:ea typeface="맑은 고딕" pitchFamily="34" charset="-122"/>
+                <a:cs typeface="맑은 고딕" pitchFamily="34" charset="-120"/>
+              </a:rPr>
+              <a:t>여유 있음</a:t>
+            </a:r>
+            <a:endParaRPr lang="en-US" sz="950" dirty="0"/>
+          </a:p>
+        </p:txBody>
+      </p:sp>
+      <p:sp>
+        <p:nvSpPr>
+          <p:cNvPr id="25" name="Shape 23"/>
+          <p:cNvSpPr/>
+          <p:nvPr/>
+        </p:nvSpPr>
+        <p:spPr>
+          <a:xfrm>
+            <a:off x="6470752" y="3529584"/>
+            <a:ext cx="2092376" cy="493776"/>
+          </a:xfrm>
+          <a:prstGeom prst="roundRect">
+            <a:avLst>
+              <a:gd name="adj" fmla="val 12963"/>
+            </a:avLst>
+          </a:prstGeom>
+          <a:solidFill>
+            <a:srgbClr val="FDF2E9"/>
+          </a:solidFill>
+          <a:ln w="12700">
+            <a:solidFill>
+              <a:srgbClr val="333333"/>
+            </a:solidFill>
+            <a:prstDash val="solid"/>
+          </a:ln>
+        </p:spPr>
+      </p:sp>
+      <p:sp>
+        <p:nvSpPr>
+          <p:cNvPr id="26" name="Text 24"/>
+          <p:cNvSpPr/>
+          <p:nvPr/>
+        </p:nvSpPr>
+        <p:spPr>
+          <a:xfrm>
+            <a:off x="6598768" y="3566160"/>
+            <a:ext cx="1836344" cy="237744"/>
+          </a:xfrm>
+          <a:prstGeom prst="rect">
+            <a:avLst/>
+          </a:prstGeom>
+          <a:noFill/>
+          <a:ln/>
+        </p:spPr>
+        <p:txBody>
+          <a:bodyPr wrap="square" lIns="0" tIns="0" rIns="0" bIns="0" rtlCol="0" anchor="ctr"/>
+          <a:lstStyle/>
+          <a:p>
+            <a:pPr indent="0" marL="0">
+              <a:buNone/>
+            </a:pPr>
+            <a:r>
+              <a:rPr lang="en-US" sz="1100" b="1" dirty="0">
+                <a:solidFill>
+                  <a:srgbClr val="E17B34"/>
+                </a:solidFill>
+                <a:latin typeface="맑은 고딕" pitchFamily="34" charset="0"/>
+                <a:ea typeface="맑은 고딕" pitchFamily="34" charset="-122"/>
+                <a:cs typeface="맑은 고딕" pitchFamily="34" charset="-120"/>
+              </a:rPr>
+              <a:t>460 ~ 520 µm</a:t>
+            </a:r>
+            <a:endParaRPr lang="en-US" sz="1100" dirty="0"/>
+          </a:p>
+        </p:txBody>
+      </p:sp>
+      <p:sp>
+        <p:nvSpPr>
+          <p:cNvPr id="27" name="Text 25"/>
+          <p:cNvSpPr/>
+          <p:nvPr/>
+        </p:nvSpPr>
+        <p:spPr>
+          <a:xfrm>
+            <a:off x="6598768" y="3785616"/>
+            <a:ext cx="1836344" cy="201168"/>
+          </a:xfrm>
+          <a:prstGeom prst="rect">
+            <a:avLst/>
+          </a:prstGeom>
+          <a:noFill/>
+          <a:ln/>
+        </p:spPr>
+        <p:txBody>
+          <a:bodyPr wrap="square" lIns="0" tIns="0" rIns="0" bIns="0" rtlCol="0" anchor="ctr"/>
+          <a:lstStyle/>
+          <a:p>
+            <a:pPr indent="0" marL="0">
+              <a:buNone/>
+            </a:pPr>
+            <a:r>
+              <a:rPr lang="en-US" sz="950" dirty="0">
+                <a:solidFill>
+                  <a:srgbClr val="3D4A5C"/>
+                </a:solidFill>
+                <a:latin typeface="맑은 고딕" pitchFamily="34" charset="0"/>
+                <a:ea typeface="맑은 고딕" pitchFamily="34" charset="-122"/>
+                <a:cs typeface="맑은 고딕" pitchFamily="34" charset="-120"/>
+              </a:rPr>
+              <a:t>ISO 통과, 여유 없음</a:t>
+            </a:r>
+            <a:endParaRPr lang="en-US" sz="950" dirty="0"/>
+          </a:p>
+        </p:txBody>
+      </p:sp>
+      <p:sp>
+        <p:nvSpPr>
+          <p:cNvPr id="28" name="Shape 26"/>
+          <p:cNvSpPr/>
+          <p:nvPr/>
+        </p:nvSpPr>
+        <p:spPr>
+          <a:xfrm>
+            <a:off x="6470752" y="4096512"/>
+            <a:ext cx="2092376" cy="493776"/>
+          </a:xfrm>
+          <a:prstGeom prst="roundRect">
+            <a:avLst>
+              <a:gd name="adj" fmla="val 12963"/>
+            </a:avLst>
+          </a:prstGeom>
+          <a:solidFill>
+            <a:srgbClr val="FDECEA"/>
+          </a:solidFill>
+          <a:ln w="12700">
+            <a:solidFill>
+              <a:srgbClr val="333333"/>
+            </a:solidFill>
+            <a:prstDash val="solid"/>
+          </a:ln>
+        </p:spPr>
+      </p:sp>
+      <p:sp>
+        <p:nvSpPr>
+          <p:cNvPr id="29" name="Text 27"/>
+          <p:cNvSpPr/>
+          <p:nvPr/>
+        </p:nvSpPr>
+        <p:spPr>
+          <a:xfrm>
+            <a:off x="6598768" y="4133088"/>
+            <a:ext cx="1836344" cy="237744"/>
+          </a:xfrm>
+          <a:prstGeom prst="rect">
+            <a:avLst/>
+          </a:prstGeom>
+          <a:noFill/>
+          <a:ln/>
+        </p:spPr>
+        <p:txBody>
+          <a:bodyPr wrap="square" lIns="0" tIns="0" rIns="0" bIns="0" rtlCol="0" anchor="ctr"/>
+          <a:lstStyle/>
+          <a:p>
+            <a:pPr indent="0" marL="0">
+              <a:buNone/>
+            </a:pPr>
+            <a:r>
+              <a:rPr lang="en-US" sz="1100" b="1" dirty="0">
+                <a:solidFill>
+                  <a:srgbClr val="C0392B"/>
+                </a:solidFill>
+                <a:latin typeface="맑은 고딕" pitchFamily="34" charset="0"/>
+                <a:ea typeface="맑은 고딕" pitchFamily="34" charset="-122"/>
+                <a:cs typeface="맑은 고딕" pitchFamily="34" charset="-120"/>
+              </a:rPr>
+              <a:t>520 µm 초과</a:t>
+            </a:r>
+            <a:endParaRPr lang="en-US" sz="1100" dirty="0"/>
+          </a:p>
+        </p:txBody>
+      </p:sp>
+      <p:sp>
+        <p:nvSpPr>
+          <p:cNvPr id="30" name="Text 28"/>
+          <p:cNvSpPr/>
+          <p:nvPr/>
+        </p:nvSpPr>
+        <p:spPr>
+          <a:xfrm>
+            <a:off x="6598768" y="4352544"/>
+            <a:ext cx="1836344" cy="201168"/>
+          </a:xfrm>
+          <a:prstGeom prst="rect">
+            <a:avLst/>
+          </a:prstGeom>
+          <a:noFill/>
+          <a:ln/>
+        </p:spPr>
+        <p:txBody>
+          <a:bodyPr wrap="square" lIns="0" tIns="0" rIns="0" bIns="0" rtlCol="0" anchor="ctr"/>
+          <a:lstStyle/>
+          <a:p>
+            <a:pPr indent="0" marL="0">
+              <a:buNone/>
+            </a:pPr>
+            <a:r>
+              <a:rPr lang="en-US" sz="950" dirty="0">
+                <a:solidFill>
+                  <a:srgbClr val="3D4A5C"/>
+                </a:solidFill>
+                <a:latin typeface="맑은 고딕" pitchFamily="34" charset="0"/>
+                <a:ea typeface="맑은 고딕" pitchFamily="34" charset="-122"/>
+                <a:cs typeface="맑은 고딕" pitchFamily="34" charset="-120"/>
+              </a:rPr>
+              <a:t>부적합</a:t>
+            </a:r>
+            <a:endParaRPr lang="en-US" sz="950" dirty="0"/>
+          </a:p>
+        </p:txBody>
+      </p:sp>
+      <p:sp>
+        <p:nvSpPr>
+          <p:cNvPr id="31" name="Text 29"/>
+          <p:cNvSpPr/>
+          <p:nvPr/>
+        </p:nvSpPr>
+        <p:spPr>
+          <a:xfrm>
+            <a:off x="6470752" y="4626864"/>
+            <a:ext cx="2092376" cy="182880"/>
+          </a:xfrm>
+          <a:prstGeom prst="rect">
+            <a:avLst/>
+          </a:prstGeom>
+          <a:noFill/>
+          <a:ln/>
+        </p:spPr>
+        <p:txBody>
+          <a:bodyPr wrap="square" lIns="0" tIns="0" rIns="0" bIns="0" rtlCol="0" anchor="ctr"/>
+          <a:lstStyle/>
+          <a:p>
+            <a:pPr indent="0" marL="0">
+              <a:buNone/>
+            </a:pPr>
+            <a:r>
+              <a:rPr lang="en-US" sz="900" i="1" dirty="0">
+                <a:solidFill>
+                  <a:srgbClr val="8A94A6"/>
+                </a:solidFill>
+                <a:latin typeface="맑은 고딕" pitchFamily="34" charset="0"/>
+                <a:ea typeface="맑은 고딕" pitchFamily="34" charset="-122"/>
+                <a:cs typeface="맑은 고딕" pitchFamily="34" charset="-120"/>
+              </a:rPr>
+              <a:t>가운데 구간이 판단이 필요한 영역입니다.</a:t>
+            </a:r>
+            <a:endParaRPr lang="en-US" sz="900" dirty="0"/>
+          </a:p>
+        </p:txBody>
+      </p:sp>
+      <p:sp>
+        <p:nvSpPr>
+          <p:cNvPr id="32" name="Text 30"/>
+          <p:cNvSpPr/>
+          <p:nvPr/>
+        </p:nvSpPr>
+        <p:spPr>
+          <a:xfrm>
+            <a:off x="9312935" y="2962656"/>
+            <a:ext cx="2092376" cy="201168"/>
+          </a:xfrm>
+          <a:prstGeom prst="rect">
+            <a:avLst/>
+          </a:prstGeom>
+          <a:noFill/>
+          <a:ln/>
+        </p:spPr>
+        <p:txBody>
+          <a:bodyPr wrap="square" lIns="0" tIns="0" rIns="0" bIns="0" rtlCol="0" anchor="ctr"/>
+          <a:lstStyle/>
+          <a:p>
+            <a:pPr indent="0" marL="0">
+              <a:buNone/>
+            </a:pPr>
+            <a:r>
+              <a:rPr lang="en-US" sz="950" dirty="0">
+                <a:solidFill>
+                  <a:srgbClr val="3D4A5C"/>
+                </a:solidFill>
+                <a:latin typeface="맑은 고딕" pitchFamily="34" charset="0"/>
+                <a:ea typeface="맑은 고딕" pitchFamily="34" charset="-122"/>
+                <a:cs typeface="맑은 고딕" pitchFamily="34" charset="-120"/>
+              </a:rPr>
+              <a:t>플런저 · 배럴 1조 단가</a:t>
+            </a:r>
+            <a:endParaRPr lang="en-US" sz="950" dirty="0"/>
+          </a:p>
+        </p:txBody>
+      </p:sp>
+      <p:sp>
+        <p:nvSpPr>
+          <p:cNvPr id="33" name="Text 31"/>
+          <p:cNvSpPr/>
+          <p:nvPr/>
+        </p:nvSpPr>
+        <p:spPr>
+          <a:xfrm>
+            <a:off x="9312935" y="3145536"/>
+            <a:ext cx="2092376" cy="237744"/>
+          </a:xfrm>
+          <a:prstGeom prst="rect">
+            <a:avLst/>
+          </a:prstGeom>
+          <a:noFill/>
+          <a:ln/>
+        </p:spPr>
+        <p:txBody>
+          <a:bodyPr wrap="square" lIns="0" tIns="0" rIns="0" bIns="0" rtlCol="0" anchor="ctr"/>
+          <a:lstStyle/>
+          <a:p>
+            <a:pPr indent="0" marL="0">
+              <a:buNone/>
+            </a:pPr>
+            <a:r>
+              <a:rPr lang="en-US" sz="1150" b="1" dirty="0">
+                <a:solidFill>
+                  <a:srgbClr val="1B3A5C"/>
+                </a:solidFill>
+                <a:latin typeface="맑은 고딕" pitchFamily="34" charset="0"/>
+                <a:ea typeface="맑은 고딕" pitchFamily="34" charset="-122"/>
+                <a:cs typeface="맑은 고딕" pitchFamily="34" charset="-120"/>
+              </a:rPr>
+              <a:t>＿＿＿＿＿ 원</a:t>
+            </a:r>
+            <a:endParaRPr lang="en-US" sz="1150" dirty="0"/>
+          </a:p>
+        </p:txBody>
+      </p:sp>
+      <p:sp>
+        <p:nvSpPr>
+          <p:cNvPr id="34" name="Text 32"/>
+          <p:cNvSpPr/>
+          <p:nvPr/>
+        </p:nvSpPr>
+        <p:spPr>
+          <a:xfrm>
+            <a:off x="9312935" y="3419856"/>
+            <a:ext cx="2092376" cy="201168"/>
+          </a:xfrm>
+          <a:prstGeom prst="rect">
+            <a:avLst/>
+          </a:prstGeom>
+          <a:noFill/>
+          <a:ln/>
+        </p:spPr>
+        <p:txBody>
+          <a:bodyPr wrap="square" lIns="0" tIns="0" rIns="0" bIns="0" rtlCol="0" anchor="ctr"/>
+          <a:lstStyle/>
+          <a:p>
+            <a:pPr indent="0" marL="0">
+              <a:buNone/>
+            </a:pPr>
+            <a:r>
+              <a:rPr lang="en-US" sz="950" dirty="0">
+                <a:solidFill>
+                  <a:srgbClr val="3D4A5C"/>
+                </a:solidFill>
+                <a:latin typeface="맑은 고딕" pitchFamily="34" charset="0"/>
+                <a:ea typeface="맑은 고딕" pitchFamily="34" charset="-122"/>
+                <a:cs typeface="맑은 고딕" pitchFamily="34" charset="-120"/>
+              </a:rPr>
+              <a:t>× 실린더 수</a:t>
+            </a:r>
+            <a:endParaRPr lang="en-US" sz="950" dirty="0"/>
+          </a:p>
+        </p:txBody>
+      </p:sp>
+      <p:sp>
+        <p:nvSpPr>
+          <p:cNvPr id="35" name="Text 33"/>
+          <p:cNvSpPr/>
+          <p:nvPr/>
+        </p:nvSpPr>
+        <p:spPr>
+          <a:xfrm>
+            <a:off x="9312935" y="3602736"/>
+            <a:ext cx="2092376" cy="237744"/>
+          </a:xfrm>
+          <a:prstGeom prst="rect">
+            <a:avLst/>
+          </a:prstGeom>
+          <a:noFill/>
+          <a:ln/>
+        </p:spPr>
+        <p:txBody>
+          <a:bodyPr wrap="square" lIns="0" tIns="0" rIns="0" bIns="0" rtlCol="0" anchor="ctr"/>
+          <a:lstStyle/>
+          <a:p>
+            <a:pPr indent="0" marL="0">
+              <a:buNone/>
+            </a:pPr>
+            <a:r>
+              <a:rPr lang="en-US" sz="1150" b="1" dirty="0">
+                <a:solidFill>
+                  <a:srgbClr val="1B3A5C"/>
+                </a:solidFill>
+                <a:latin typeface="맑은 고딕" pitchFamily="34" charset="0"/>
+                <a:ea typeface="맑은 고딕" pitchFamily="34" charset="-122"/>
+                <a:cs typeface="맑은 고딕" pitchFamily="34" charset="-120"/>
+              </a:rPr>
+              <a:t>＿＿＿ 기</a:t>
+            </a:r>
+            <a:endParaRPr lang="en-US" sz="1150" dirty="0"/>
+          </a:p>
+        </p:txBody>
+      </p:sp>
+      <p:sp>
+        <p:nvSpPr>
+          <p:cNvPr id="36" name="Text 34"/>
+          <p:cNvSpPr/>
+          <p:nvPr/>
+        </p:nvSpPr>
+        <p:spPr>
+          <a:xfrm>
+            <a:off x="9312935" y="3877056"/>
+            <a:ext cx="2092376" cy="201168"/>
+          </a:xfrm>
+          <a:prstGeom prst="rect">
+            <a:avLst/>
+          </a:prstGeom>
+          <a:noFill/>
+          <a:ln/>
+        </p:spPr>
+        <p:txBody>
+          <a:bodyPr wrap="square" lIns="0" tIns="0" rIns="0" bIns="0" rtlCol="0" anchor="ctr"/>
+          <a:lstStyle/>
+          <a:p>
+            <a:pPr indent="0" marL="0">
+              <a:buNone/>
+            </a:pPr>
+            <a:r>
+              <a:rPr lang="en-US" sz="950" dirty="0">
+                <a:solidFill>
+                  <a:srgbClr val="3D4A5C"/>
+                </a:solidFill>
+                <a:latin typeface="맑은 고딕" pitchFamily="34" charset="0"/>
+                <a:ea typeface="맑은 고딕" pitchFamily="34" charset="-122"/>
+                <a:cs typeface="맑은 고딕" pitchFamily="34" charset="-120"/>
+              </a:rPr>
+              <a:t>첨가제 (50 t 벙커 기준)</a:t>
+            </a:r>
+            <a:endParaRPr lang="en-US" sz="950" dirty="0"/>
+          </a:p>
+        </p:txBody>
+      </p:sp>
+      <p:sp>
+        <p:nvSpPr>
+          <p:cNvPr id="37" name="Text 35"/>
+          <p:cNvSpPr/>
+          <p:nvPr/>
+        </p:nvSpPr>
+        <p:spPr>
+          <a:xfrm>
+            <a:off x="9312935" y="4059936"/>
+            <a:ext cx="2092376" cy="237744"/>
+          </a:xfrm>
+          <a:prstGeom prst="rect">
+            <a:avLst/>
+          </a:prstGeom>
+          <a:noFill/>
+          <a:ln/>
+        </p:spPr>
+        <p:txBody>
+          <a:bodyPr wrap="square" lIns="0" tIns="0" rIns="0" bIns="0" rtlCol="0" anchor="ctr"/>
+          <a:lstStyle/>
+          <a:p>
+            <a:pPr indent="0" marL="0">
+              <a:buNone/>
+            </a:pPr>
+            <a:r>
+              <a:rPr lang="en-US" sz="1150" b="1" dirty="0">
+                <a:solidFill>
+                  <a:srgbClr val="2E7D5B"/>
+                </a:solidFill>
+                <a:latin typeface="맑은 고딕" pitchFamily="34" charset="0"/>
+                <a:ea typeface="맑은 고딕" pitchFamily="34" charset="-122"/>
+                <a:cs typeface="맑은 고딕" pitchFamily="34" charset="-120"/>
+              </a:rPr>
+              <a:t>5 ~ 10 L</a:t>
+            </a:r>
+            <a:endParaRPr lang="en-US" sz="1150" dirty="0"/>
+          </a:p>
+        </p:txBody>
+      </p:sp>
+      <p:sp>
+        <p:nvSpPr>
+          <p:cNvPr id="38" name="Shape 36"/>
+          <p:cNvSpPr/>
+          <p:nvPr/>
+        </p:nvSpPr>
+        <p:spPr>
+          <a:xfrm>
+            <a:off x="9312935" y="4370832"/>
+            <a:ext cx="2092376" cy="438912"/>
+          </a:xfrm>
+          <a:prstGeom prst="roundRect">
+            <a:avLst>
+              <a:gd name="adj" fmla="val 14583"/>
+            </a:avLst>
+          </a:prstGeom>
+          <a:solidFill>
+            <a:srgbClr val="1B3A5C"/>
+          </a:solidFill>
+          <a:ln w="12700">
+            <a:solidFill>
+              <a:srgbClr val="333333"/>
+            </a:solidFill>
+            <a:prstDash val="solid"/>
+          </a:ln>
+        </p:spPr>
+      </p:sp>
+      <p:sp>
+        <p:nvSpPr>
+          <p:cNvPr id="39" name="Text 37"/>
+          <p:cNvSpPr/>
+          <p:nvPr/>
+        </p:nvSpPr>
+        <p:spPr>
+          <a:xfrm>
+            <a:off x="9312935" y="4370832"/>
+            <a:ext cx="2092376" cy="438912"/>
+          </a:xfrm>
+          <a:prstGeom prst="rect">
+            <a:avLst/>
+          </a:prstGeom>
+          <a:noFill/>
+          <a:ln/>
+        </p:spPr>
+        <p:txBody>
+          <a:bodyPr wrap="square" lIns="0" tIns="0" rIns="0" bIns="0" rtlCol="0" anchor="ctr"/>
+          <a:lstStyle/>
+          <a:p>
+            <a:pPr algn="ctr" indent="0" marL="0">
+              <a:buNone/>
+            </a:pPr>
+            <a:r>
+              <a:rPr lang="en-US" sz="1150" b="1" dirty="0">
+                <a:solidFill>
+                  <a:srgbClr val="E17B34"/>
+                </a:solidFill>
+                <a:latin typeface="맑은 고딕" pitchFamily="34" charset="0"/>
+                <a:ea typeface="맑은 고딕" pitchFamily="34" charset="-122"/>
+                <a:cs typeface="맑은 고딕" pitchFamily="34" charset="-120"/>
+              </a:rPr>
+              <a:t>어느 쪽이 큽니까?</a:t>
+            </a:r>
+            <a:endParaRPr lang="en-US" sz="1150" dirty="0"/>
+          </a:p>
+        </p:txBody>
+      </p:sp>
+      <p:sp>
+        <p:nvSpPr>
+          <p:cNvPr id="40" name="Shape 38"/>
+          <p:cNvSpPr/>
+          <p:nvPr/>
+        </p:nvSpPr>
+        <p:spPr>
+          <a:xfrm>
+            <a:off x="566928" y="4992624"/>
+            <a:ext cx="11057839" cy="786384"/>
+          </a:xfrm>
+          <a:prstGeom prst="roundRect">
+            <a:avLst>
+              <a:gd name="adj" fmla="val 11628"/>
+            </a:avLst>
+          </a:prstGeom>
+          <a:solidFill>
+            <a:srgbClr val="1B3A5C"/>
+          </a:solidFill>
+          <a:ln w="12700">
+            <a:solidFill>
+              <a:srgbClr val="1B3A5C"/>
+            </a:solidFill>
+            <a:prstDash val="solid"/>
+          </a:ln>
+        </p:spPr>
+      </p:sp>
+      <p:sp>
+        <p:nvSpPr>
+          <p:cNvPr id="41" name="Text 39"/>
+          <p:cNvSpPr/>
+          <p:nvPr/>
+        </p:nvSpPr>
+        <p:spPr>
+          <a:xfrm>
+            <a:off x="795528" y="4992624"/>
+            <a:ext cx="10600639" cy="786384"/>
+          </a:xfrm>
+          <a:prstGeom prst="rect">
+            <a:avLst/>
+          </a:prstGeom>
+          <a:noFill/>
+          <a:ln/>
+        </p:spPr>
+        <p:txBody>
+          <a:bodyPr wrap="square" lIns="0" tIns="0" rIns="0" bIns="0" rtlCol="0" anchor="ctr"/>
+          <a:lstStyle/>
+          <a:p>
+            <a:pPr algn="ctr" indent="0" marL="0">
+              <a:buNone/>
+            </a:pPr>
+            <a:r>
+              <a:rPr lang="en-US" sz="1700" b="1" dirty="0">
+                <a:solidFill>
+                  <a:srgbClr val="E17B34"/>
+                </a:solidFill>
+                <a:latin typeface="바탕" pitchFamily="34" charset="0"/>
+                <a:ea typeface="바탕" pitchFamily="34" charset="-122"/>
+                <a:cs typeface="바탕" pitchFamily="34" charset="-120"/>
+              </a:rPr>
+              <a:t>“ </a:t>
+            </a:r>
+            <a:pPr algn="ctr" indent="0" marL="0">
+              <a:buNone/>
+            </a:pPr>
+            <a:r>
+              <a:rPr lang="en-US" sz="1400" b="1" dirty="0">
+                <a:solidFill>
+                  <a:srgbClr val="FFFFFF"/>
+                </a:solidFill>
+                <a:latin typeface="맑은 고딕" pitchFamily="34" charset="0"/>
+                <a:ea typeface="맑은 고딕" pitchFamily="34" charset="-122"/>
+                <a:cs typeface="맑은 고딕" pitchFamily="34" charset="-120"/>
+              </a:rPr>
+              <a:t>윤활성은 계기판에 뜨지 않습니다. 성적서를 열어보는 것 말고는 알 방법이 없습니다.</a:t>
+            </a:r>
+            <a:pPr algn="ctr" indent="0" marL="0">
+              <a:buNone/>
+            </a:pPr>
+            <a:r>
+              <a:rPr lang="en-US" sz="1700" b="1" dirty="0">
+                <a:solidFill>
+                  <a:srgbClr val="E17B34"/>
+                </a:solidFill>
+                <a:latin typeface="바탕" pitchFamily="34" charset="0"/>
+                <a:ea typeface="바탕" pitchFamily="34" charset="-122"/>
+                <a:cs typeface="바탕" pitchFamily="34" charset="-120"/>
+              </a:rPr>
+              <a:t> ”</a:t>
+            </a:r>
+            <a:endParaRPr lang="en-US" sz="1700" dirty="0"/>
+          </a:p>
+        </p:txBody>
+      </p:sp>
+      <p:sp>
+        <p:nvSpPr>
+          <p:cNvPr id="42" name="Text 40"/>
+          <p:cNvSpPr/>
+          <p:nvPr/>
+        </p:nvSpPr>
+        <p:spPr>
+          <a:xfrm>
+            <a:off x="566928" y="5907024"/>
+            <a:ext cx="11057839" cy="219456"/>
+          </a:xfrm>
+          <a:prstGeom prst="rect">
+            <a:avLst/>
+          </a:prstGeom>
+          <a:noFill/>
+          <a:ln/>
+        </p:spPr>
+        <p:txBody>
+          <a:bodyPr wrap="square" lIns="0" tIns="0" rIns="0" bIns="0" rtlCol="0" anchor="ctr"/>
+          <a:lstStyle/>
+          <a:p>
+            <a:pPr indent="0" marL="0">
+              <a:buNone/>
+            </a:pPr>
+            <a:r>
+              <a:rPr lang="en-US" sz="850" i="1" dirty="0">
+                <a:solidFill>
+                  <a:srgbClr val="8A94A6"/>
+                </a:solidFill>
+                <a:latin typeface="맑은 고딕" pitchFamily="34" charset="0"/>
+                <a:ea typeface="맑은 고딕" pitchFamily="34" charset="-122"/>
+                <a:cs typeface="맑은 고딕" pitchFamily="34" charset="-120"/>
+              </a:rPr>
+              <a:t>ISO 8217 · EN 590 규격 한계 · 투입량은 Unitor™ DieselPower™ Lubricity 제품 매뉴얼 기준 (0.1~0.2 L/ton)</a:t>
+            </a:r>
+            <a:endParaRPr lang="en-US" sz="850" dirty="0"/>
+          </a:p>
+        </p:txBody>
+      </p:sp>
+    </p:spTree>
+  </p:cSld>
+  <p:clrMapOvr>
+    <a:masterClrMapping/>
+  </p:clrMapOvr>
+</p:sld>
+</file>
+
 <file path=ppt/slides/slide2.xml><?xml version="1.0" encoding="utf-8"?>
 <p:sld xmlns:a="http://schemas.openxmlformats.org/drawingml/2006/main" xmlns:r="http://schemas.openxmlformats.org/officeDocument/2006/relationships" xmlns:p="http://schemas.openxmlformats.org/presentationml/2006/main">
   <p:cSld name="Slide 2">

</xml_diff>